<commit_message>
prueba de buzon de sugerencias
se añade la funcionalidad de el buzon de sugerencias y reclamos, en esta los usuarios pueden poner reclamos y sugerencias a administracion para tener trazabilidad de estos
</commit_message>
<xml_diff>
--- a/manual de uso/capacitacion/Capacitacion sistema de inventario.pptx
+++ b/manual de uso/capacitacion/Capacitacion sistema de inventario.pptx
@@ -4,19 +4,23 @@
   <p:sldMasterIdLst>
     <p:sldMasterId id="2147483688" r:id="rId1"/>
   </p:sldMasterIdLst>
+  <p:notesMasterIdLst>
+    <p:notesMasterId r:id="rId15"/>
+  </p:notesMasterIdLst>
   <p:sldIdLst>
     <p:sldId id="256" r:id="rId2"/>
     <p:sldId id="257" r:id="rId3"/>
     <p:sldId id="258" r:id="rId4"/>
     <p:sldId id="259" r:id="rId5"/>
-    <p:sldId id="260" r:id="rId6"/>
-    <p:sldId id="261" r:id="rId7"/>
-    <p:sldId id="262" r:id="rId8"/>
-    <p:sldId id="263" r:id="rId9"/>
-    <p:sldId id="264" r:id="rId10"/>
-    <p:sldId id="265" r:id="rId11"/>
-    <p:sldId id="266" r:id="rId12"/>
-    <p:sldId id="267" r:id="rId13"/>
+    <p:sldId id="268" r:id="rId6"/>
+    <p:sldId id="260" r:id="rId7"/>
+    <p:sldId id="261" r:id="rId8"/>
+    <p:sldId id="262" r:id="rId9"/>
+    <p:sldId id="263" r:id="rId10"/>
+    <p:sldId id="264" r:id="rId11"/>
+    <p:sldId id="265" r:id="rId12"/>
+    <p:sldId id="266" r:id="rId13"/>
+    <p:sldId id="267" r:id="rId14"/>
   </p:sldIdLst>
   <p:sldSz cx="12192000" cy="6858000"/>
   <p:notesSz cx="6858000" cy="9144000"/>
@@ -123,6 +127,440 @@
 </p:presentation>
 </file>
 
+<file path=ppt/notesMasters/notesMaster1.xml><?xml version="1.0" encoding="utf-8"?>
+<p:notesMaster xmlns:a="http://schemas.openxmlformats.org/drawingml/2006/main" xmlns:r="http://schemas.openxmlformats.org/officeDocument/2006/relationships" xmlns:p="http://schemas.openxmlformats.org/presentationml/2006/main">
+  <p:cSld>
+    <p:bg>
+      <p:bgRef idx="1001">
+        <a:schemeClr val="bg1"/>
+      </p:bgRef>
+    </p:bg>
+    <p:spTree>
+      <p:nvGrpSpPr>
+        <p:cNvPr id="1" name=""/>
+        <p:cNvGrpSpPr/>
+        <p:nvPr/>
+      </p:nvGrpSpPr>
+      <p:grpSpPr>
+        <a:xfrm>
+          <a:off x="0" y="0"/>
+          <a:ext cx="0" cy="0"/>
+          <a:chOff x="0" y="0"/>
+          <a:chExt cx="0" cy="0"/>
+        </a:xfrm>
+      </p:grpSpPr>
+      <p:sp>
+        <p:nvSpPr>
+          <p:cNvPr id="2" name="Marcador de encabezado 1"/>
+          <p:cNvSpPr>
+            <a:spLocks noGrp="1"/>
+          </p:cNvSpPr>
+          <p:nvPr>
+            <p:ph type="hdr" sz="quarter"/>
+          </p:nvPr>
+        </p:nvSpPr>
+        <p:spPr>
+          <a:xfrm>
+            <a:off x="0" y="0"/>
+            <a:ext cx="2971800" cy="458788"/>
+          </a:xfrm>
+          <a:prstGeom prst="rect">
+            <a:avLst/>
+          </a:prstGeom>
+        </p:spPr>
+        <p:txBody>
+          <a:bodyPr vert="horz" lIns="91440" tIns="45720" rIns="91440" bIns="45720" rtlCol="0"/>
+          <a:lstStyle>
+            <a:lvl1pPr algn="l">
+              <a:defRPr sz="1200"/>
+            </a:lvl1pPr>
+          </a:lstStyle>
+          <a:p>
+            <a:endParaRPr lang="es-CL"/>
+          </a:p>
+        </p:txBody>
+      </p:sp>
+      <p:sp>
+        <p:nvSpPr>
+          <p:cNvPr id="3" name="Marcador de fecha 2"/>
+          <p:cNvSpPr>
+            <a:spLocks noGrp="1"/>
+          </p:cNvSpPr>
+          <p:nvPr>
+            <p:ph type="dt" idx="1"/>
+          </p:nvPr>
+        </p:nvSpPr>
+        <p:spPr>
+          <a:xfrm>
+            <a:off x="3884613" y="0"/>
+            <a:ext cx="2971800" cy="458788"/>
+          </a:xfrm>
+          <a:prstGeom prst="rect">
+            <a:avLst/>
+          </a:prstGeom>
+        </p:spPr>
+        <p:txBody>
+          <a:bodyPr vert="horz" lIns="91440" tIns="45720" rIns="91440" bIns="45720" rtlCol="0"/>
+          <a:lstStyle>
+            <a:lvl1pPr algn="r">
+              <a:defRPr sz="1200"/>
+            </a:lvl1pPr>
+          </a:lstStyle>
+          <a:p>
+            <a:fld id="{0AD60E13-1931-4BC3-A76B-686F079AFBC9}" type="datetimeFigureOut">
+              <a:rPr lang="es-CL" smtClean="0"/>
+              <a:t>27-10-2026</a:t>
+            </a:fld>
+            <a:endParaRPr lang="es-CL"/>
+          </a:p>
+        </p:txBody>
+      </p:sp>
+      <p:sp>
+        <p:nvSpPr>
+          <p:cNvPr id="4" name="Marcador de imagen de diapositiva 3"/>
+          <p:cNvSpPr>
+            <a:spLocks noGrp="1" noRot="1" noChangeAspect="1"/>
+          </p:cNvSpPr>
+          <p:nvPr>
+            <p:ph type="sldImg" idx="2"/>
+          </p:nvPr>
+        </p:nvSpPr>
+        <p:spPr>
+          <a:xfrm>
+            <a:off x="685800" y="1143000"/>
+            <a:ext cx="5486400" cy="3086100"/>
+          </a:xfrm>
+          <a:prstGeom prst="rect">
+            <a:avLst/>
+          </a:prstGeom>
+          <a:noFill/>
+          <a:ln w="12700">
+            <a:solidFill>
+              <a:prstClr val="black"/>
+            </a:solidFill>
+          </a:ln>
+        </p:spPr>
+        <p:txBody>
+          <a:bodyPr vert="horz" lIns="91440" tIns="45720" rIns="91440" bIns="45720" rtlCol="0" anchor="ctr"/>
+          <a:lstStyle/>
+          <a:p>
+            <a:endParaRPr lang="es-CL"/>
+          </a:p>
+        </p:txBody>
+      </p:sp>
+      <p:sp>
+        <p:nvSpPr>
+          <p:cNvPr id="5" name="Marcador de notas 4"/>
+          <p:cNvSpPr>
+            <a:spLocks noGrp="1"/>
+          </p:cNvSpPr>
+          <p:nvPr>
+            <p:ph type="body" sz="quarter" idx="3"/>
+          </p:nvPr>
+        </p:nvSpPr>
+        <p:spPr>
+          <a:xfrm>
+            <a:off x="685800" y="4400550"/>
+            <a:ext cx="5486400" cy="3600450"/>
+          </a:xfrm>
+          <a:prstGeom prst="rect">
+            <a:avLst/>
+          </a:prstGeom>
+        </p:spPr>
+        <p:txBody>
+          <a:bodyPr vert="horz" lIns="91440" tIns="45720" rIns="91440" bIns="45720" rtlCol="0"/>
+          <a:lstStyle/>
+          <a:p>
+            <a:pPr lvl="0"/>
+            <a:r>
+              <a:rPr lang="es-MX"/>
+              <a:t>Haga clic para modificar los estilos de texto del patrón</a:t>
+            </a:r>
+          </a:p>
+          <a:p>
+            <a:pPr lvl="1"/>
+            <a:r>
+              <a:rPr lang="es-MX"/>
+              <a:t>Segundo nivel</a:t>
+            </a:r>
+          </a:p>
+          <a:p>
+            <a:pPr lvl="2"/>
+            <a:r>
+              <a:rPr lang="es-MX"/>
+              <a:t>Tercer nivel</a:t>
+            </a:r>
+          </a:p>
+          <a:p>
+            <a:pPr lvl="3"/>
+            <a:r>
+              <a:rPr lang="es-MX"/>
+              <a:t>Cuarto nivel</a:t>
+            </a:r>
+          </a:p>
+          <a:p>
+            <a:pPr lvl="4"/>
+            <a:r>
+              <a:rPr lang="es-MX"/>
+              <a:t>Quinto nivel</a:t>
+            </a:r>
+            <a:endParaRPr lang="es-CL"/>
+          </a:p>
+        </p:txBody>
+      </p:sp>
+      <p:sp>
+        <p:nvSpPr>
+          <p:cNvPr id="6" name="Marcador de pie de página 5"/>
+          <p:cNvSpPr>
+            <a:spLocks noGrp="1"/>
+          </p:cNvSpPr>
+          <p:nvPr>
+            <p:ph type="ftr" sz="quarter" idx="4"/>
+          </p:nvPr>
+        </p:nvSpPr>
+        <p:spPr>
+          <a:xfrm>
+            <a:off x="0" y="8685213"/>
+            <a:ext cx="2971800" cy="458787"/>
+          </a:xfrm>
+          <a:prstGeom prst="rect">
+            <a:avLst/>
+          </a:prstGeom>
+        </p:spPr>
+        <p:txBody>
+          <a:bodyPr vert="horz" lIns="91440" tIns="45720" rIns="91440" bIns="45720" rtlCol="0" anchor="b"/>
+          <a:lstStyle>
+            <a:lvl1pPr algn="l">
+              <a:defRPr sz="1200"/>
+            </a:lvl1pPr>
+          </a:lstStyle>
+          <a:p>
+            <a:endParaRPr lang="es-CL"/>
+          </a:p>
+        </p:txBody>
+      </p:sp>
+      <p:sp>
+        <p:nvSpPr>
+          <p:cNvPr id="7" name="Marcador de número de diapositiva 6"/>
+          <p:cNvSpPr>
+            <a:spLocks noGrp="1"/>
+          </p:cNvSpPr>
+          <p:nvPr>
+            <p:ph type="sldNum" sz="quarter" idx="5"/>
+          </p:nvPr>
+        </p:nvSpPr>
+        <p:spPr>
+          <a:xfrm>
+            <a:off x="3884613" y="8685213"/>
+            <a:ext cx="2971800" cy="458787"/>
+          </a:xfrm>
+          <a:prstGeom prst="rect">
+            <a:avLst/>
+          </a:prstGeom>
+        </p:spPr>
+        <p:txBody>
+          <a:bodyPr vert="horz" lIns="91440" tIns="45720" rIns="91440" bIns="45720" rtlCol="0" anchor="b"/>
+          <a:lstStyle>
+            <a:lvl1pPr algn="r">
+              <a:defRPr sz="1200"/>
+            </a:lvl1pPr>
+          </a:lstStyle>
+          <a:p>
+            <a:fld id="{7D216FCC-FCA4-43CA-A000-4556656D4736}" type="slidenum">
+              <a:rPr lang="es-CL" smtClean="0"/>
+              <a:t>‹Nº›</a:t>
+            </a:fld>
+            <a:endParaRPr lang="es-CL"/>
+          </a:p>
+        </p:txBody>
+      </p:sp>
+    </p:spTree>
+    <p:extLst>
+      <p:ext uri="{BB962C8B-B14F-4D97-AF65-F5344CB8AC3E}">
+        <p14:creationId xmlns:p14="http://schemas.microsoft.com/office/powerpoint/2010/main" val="217035351"/>
+      </p:ext>
+    </p:extLst>
+  </p:cSld>
+  <p:clrMap bg1="lt1" tx1="dk1" bg2="lt2" tx2="dk2" accent1="accent1" accent2="accent2" accent3="accent3" accent4="accent4" accent5="accent5" accent6="accent6" hlink="hlink" folHlink="folHlink"/>
+  <p:notesStyle>
+    <a:lvl1pPr marL="0" algn="l" defTabSz="914400" rtl="0" eaLnBrk="1" latinLnBrk="0" hangingPunct="1">
+      <a:defRPr sz="1200" kern="1200">
+        <a:solidFill>
+          <a:schemeClr val="tx1"/>
+        </a:solidFill>
+        <a:latin typeface="+mn-lt"/>
+        <a:ea typeface="+mn-ea"/>
+        <a:cs typeface="+mn-cs"/>
+      </a:defRPr>
+    </a:lvl1pPr>
+    <a:lvl2pPr marL="457200" algn="l" defTabSz="914400" rtl="0" eaLnBrk="1" latinLnBrk="0" hangingPunct="1">
+      <a:defRPr sz="1200" kern="1200">
+        <a:solidFill>
+          <a:schemeClr val="tx1"/>
+        </a:solidFill>
+        <a:latin typeface="+mn-lt"/>
+        <a:ea typeface="+mn-ea"/>
+        <a:cs typeface="+mn-cs"/>
+      </a:defRPr>
+    </a:lvl2pPr>
+    <a:lvl3pPr marL="914400" algn="l" defTabSz="914400" rtl="0" eaLnBrk="1" latinLnBrk="0" hangingPunct="1">
+      <a:defRPr sz="1200" kern="1200">
+        <a:solidFill>
+          <a:schemeClr val="tx1"/>
+        </a:solidFill>
+        <a:latin typeface="+mn-lt"/>
+        <a:ea typeface="+mn-ea"/>
+        <a:cs typeface="+mn-cs"/>
+      </a:defRPr>
+    </a:lvl3pPr>
+    <a:lvl4pPr marL="1371600" algn="l" defTabSz="914400" rtl="0" eaLnBrk="1" latinLnBrk="0" hangingPunct="1">
+      <a:defRPr sz="1200" kern="1200">
+        <a:solidFill>
+          <a:schemeClr val="tx1"/>
+        </a:solidFill>
+        <a:latin typeface="+mn-lt"/>
+        <a:ea typeface="+mn-ea"/>
+        <a:cs typeface="+mn-cs"/>
+      </a:defRPr>
+    </a:lvl4pPr>
+    <a:lvl5pPr marL="1828800" algn="l" defTabSz="914400" rtl="0" eaLnBrk="1" latinLnBrk="0" hangingPunct="1">
+      <a:defRPr sz="1200" kern="1200">
+        <a:solidFill>
+          <a:schemeClr val="tx1"/>
+        </a:solidFill>
+        <a:latin typeface="+mn-lt"/>
+        <a:ea typeface="+mn-ea"/>
+        <a:cs typeface="+mn-cs"/>
+      </a:defRPr>
+    </a:lvl5pPr>
+    <a:lvl6pPr marL="2286000" algn="l" defTabSz="914400" rtl="0" eaLnBrk="1" latinLnBrk="0" hangingPunct="1">
+      <a:defRPr sz="1200" kern="1200">
+        <a:solidFill>
+          <a:schemeClr val="tx1"/>
+        </a:solidFill>
+        <a:latin typeface="+mn-lt"/>
+        <a:ea typeface="+mn-ea"/>
+        <a:cs typeface="+mn-cs"/>
+      </a:defRPr>
+    </a:lvl6pPr>
+    <a:lvl7pPr marL="2743200" algn="l" defTabSz="914400" rtl="0" eaLnBrk="1" latinLnBrk="0" hangingPunct="1">
+      <a:defRPr sz="1200" kern="1200">
+        <a:solidFill>
+          <a:schemeClr val="tx1"/>
+        </a:solidFill>
+        <a:latin typeface="+mn-lt"/>
+        <a:ea typeface="+mn-ea"/>
+        <a:cs typeface="+mn-cs"/>
+      </a:defRPr>
+    </a:lvl7pPr>
+    <a:lvl8pPr marL="3200400" algn="l" defTabSz="914400" rtl="0" eaLnBrk="1" latinLnBrk="0" hangingPunct="1">
+      <a:defRPr sz="1200" kern="1200">
+        <a:solidFill>
+          <a:schemeClr val="tx1"/>
+        </a:solidFill>
+        <a:latin typeface="+mn-lt"/>
+        <a:ea typeface="+mn-ea"/>
+        <a:cs typeface="+mn-cs"/>
+      </a:defRPr>
+    </a:lvl8pPr>
+    <a:lvl9pPr marL="3657600" algn="l" defTabSz="914400" rtl="0" eaLnBrk="1" latinLnBrk="0" hangingPunct="1">
+      <a:defRPr sz="1200" kern="1200">
+        <a:solidFill>
+          <a:schemeClr val="tx1"/>
+        </a:solidFill>
+        <a:latin typeface="+mn-lt"/>
+        <a:ea typeface="+mn-ea"/>
+        <a:cs typeface="+mn-cs"/>
+      </a:defRPr>
+    </a:lvl9pPr>
+  </p:notesStyle>
+</p:notesMaster>
+</file>
+
+<file path=ppt/notesSlides/notesSlide1.xml><?xml version="1.0" encoding="utf-8"?>
+<p:notes xmlns:a="http://schemas.openxmlformats.org/drawingml/2006/main" xmlns:r="http://schemas.openxmlformats.org/officeDocument/2006/relationships" xmlns:p="http://schemas.openxmlformats.org/presentationml/2006/main">
+  <p:cSld>
+    <p:spTree>
+      <p:nvGrpSpPr>
+        <p:cNvPr id="1" name=""/>
+        <p:cNvGrpSpPr/>
+        <p:nvPr/>
+      </p:nvGrpSpPr>
+      <p:grpSpPr>
+        <a:xfrm>
+          <a:off x="0" y="0"/>
+          <a:ext cx="0" cy="0"/>
+          <a:chOff x="0" y="0"/>
+          <a:chExt cx="0" cy="0"/>
+        </a:xfrm>
+      </p:grpSpPr>
+      <p:sp>
+        <p:nvSpPr>
+          <p:cNvPr id="2" name="Marcador de imagen de diapositiva 1"/>
+          <p:cNvSpPr>
+            <a:spLocks noGrp="1" noRot="1" noChangeAspect="1"/>
+          </p:cNvSpPr>
+          <p:nvPr>
+            <p:ph type="sldImg"/>
+          </p:nvPr>
+        </p:nvSpPr>
+        <p:spPr/>
+      </p:sp>
+      <p:sp>
+        <p:nvSpPr>
+          <p:cNvPr id="3" name="Marcador de notas 2"/>
+          <p:cNvSpPr>
+            <a:spLocks noGrp="1"/>
+          </p:cNvSpPr>
+          <p:nvPr>
+            <p:ph type="body" idx="1"/>
+          </p:nvPr>
+        </p:nvSpPr>
+        <p:spPr/>
+        <p:txBody>
+          <a:bodyPr/>
+          <a:lstStyle/>
+          <a:p>
+            <a:endParaRPr lang="es-CL" dirty="0"/>
+          </a:p>
+        </p:txBody>
+      </p:sp>
+      <p:sp>
+        <p:nvSpPr>
+          <p:cNvPr id="4" name="Marcador de número de diapositiva 3"/>
+          <p:cNvSpPr>
+            <a:spLocks noGrp="1"/>
+          </p:cNvSpPr>
+          <p:nvPr>
+            <p:ph type="sldNum" sz="quarter" idx="5"/>
+          </p:nvPr>
+        </p:nvSpPr>
+        <p:spPr/>
+        <p:txBody>
+          <a:bodyPr/>
+          <a:lstStyle/>
+          <a:p>
+            <a:fld id="{7D216FCC-FCA4-43CA-A000-4556656D4736}" type="slidenum">
+              <a:rPr lang="es-CL" smtClean="0"/>
+              <a:t>10</a:t>
+            </a:fld>
+            <a:endParaRPr lang="es-CL"/>
+          </a:p>
+        </p:txBody>
+      </p:sp>
+    </p:spTree>
+    <p:extLst>
+      <p:ext uri="{BB962C8B-B14F-4D97-AF65-F5344CB8AC3E}">
+        <p14:creationId xmlns:p14="http://schemas.microsoft.com/office/powerpoint/2010/main" val="341431240"/>
+      </p:ext>
+    </p:extLst>
+  </p:cSld>
+  <p:clrMapOvr>
+    <a:masterClrMapping/>
+  </p:clrMapOvr>
+</p:notes>
+</file>
+
 <file path=ppt/slideLayouts/slideLayout1.xml><?xml version="1.0" encoding="utf-8"?>
 <p:sldLayout xmlns:a="http://schemas.openxmlformats.org/drawingml/2006/main" xmlns:r="http://schemas.openxmlformats.org/officeDocument/2006/relationships" xmlns:p="http://schemas.openxmlformats.org/presentationml/2006/main" type="title" preserve="1">
   <p:cSld name="Title">
@@ -328,7 +766,7 @@
           <a:p>
             <a:fld id="{2A840DB8-5904-49B0-B377-D22D79484B31}" type="datetimeFigureOut">
               <a:rPr lang="es-CL" smtClean="0"/>
-              <a:t>26-10-2026</a:t>
+              <a:t>27-10-2026</a:t>
             </a:fld>
             <a:endParaRPr lang="es-CL"/>
           </a:p>
@@ -858,7 +1296,7 @@
           <a:p>
             <a:fld id="{2A840DB8-5904-49B0-B377-D22D79484B31}" type="datetimeFigureOut">
               <a:rPr lang="es-CL" smtClean="0"/>
-              <a:t>26-10-2026</a:t>
+              <a:t>27-10-2026</a:t>
             </a:fld>
             <a:endParaRPr lang="es-CL"/>
           </a:p>
@@ -1414,7 +1852,7 @@
           <a:p>
             <a:fld id="{2A840DB8-5904-49B0-B377-D22D79484B31}" type="datetimeFigureOut">
               <a:rPr lang="es-CL" smtClean="0"/>
-              <a:t>26-10-2026</a:t>
+              <a:t>27-10-2026</a:t>
             </a:fld>
             <a:endParaRPr lang="es-CL"/>
           </a:p>
@@ -1887,7 +2325,7 @@
           <a:p>
             <a:fld id="{2A840DB8-5904-49B0-B377-D22D79484B31}" type="datetimeFigureOut">
               <a:rPr lang="es-CL" smtClean="0"/>
-              <a:t>26-10-2026</a:t>
+              <a:t>27-10-2026</a:t>
             </a:fld>
             <a:endParaRPr lang="es-CL"/>
           </a:p>
@@ -2531,7 +2969,7 @@
           <a:p>
             <a:fld id="{2A840DB8-5904-49B0-B377-D22D79484B31}" type="datetimeFigureOut">
               <a:rPr lang="es-CL" smtClean="0"/>
-              <a:t>26-10-2026</a:t>
+              <a:t>27-10-2026</a:t>
             </a:fld>
             <a:endParaRPr lang="es-CL"/>
           </a:p>
@@ -3000,7 +3438,7 @@
           <a:p>
             <a:fld id="{2A840DB8-5904-49B0-B377-D22D79484B31}" type="datetimeFigureOut">
               <a:rPr lang="es-CL" smtClean="0"/>
-              <a:t>26-10-2026</a:t>
+              <a:t>27-10-2026</a:t>
             </a:fld>
             <a:endParaRPr lang="es-CL"/>
           </a:p>
@@ -3569,7 +4007,7 @@
           <a:p>
             <a:fld id="{2A840DB8-5904-49B0-B377-D22D79484B31}" type="datetimeFigureOut">
               <a:rPr lang="es-CL" smtClean="0"/>
-              <a:t>26-10-2026</a:t>
+              <a:t>27-10-2026</a:t>
             </a:fld>
             <a:endParaRPr lang="es-CL"/>
           </a:p>
@@ -4044,7 +4482,7 @@
           <a:p>
             <a:fld id="{2A840DB8-5904-49B0-B377-D22D79484B31}" type="datetimeFigureOut">
               <a:rPr lang="es-CL" smtClean="0"/>
-              <a:t>26-10-2026</a:t>
+              <a:t>27-10-2026</a:t>
             </a:fld>
             <a:endParaRPr lang="es-CL"/>
           </a:p>
@@ -4459,7 +4897,7 @@
           <a:p>
             <a:fld id="{2A840DB8-5904-49B0-B377-D22D79484B31}" type="datetimeFigureOut">
               <a:rPr lang="es-CL" smtClean="0"/>
-              <a:t>26-10-2026</a:t>
+              <a:t>27-10-2026</a:t>
             </a:fld>
             <a:endParaRPr lang="es-CL"/>
           </a:p>
@@ -4883,7 +5321,7 @@
           <a:p>
             <a:fld id="{2A840DB8-5904-49B0-B377-D22D79484B31}" type="datetimeFigureOut">
               <a:rPr lang="es-CL" smtClean="0"/>
-              <a:t>26-10-2026</a:t>
+              <a:t>27-10-2026</a:t>
             </a:fld>
             <a:endParaRPr lang="es-CL"/>
           </a:p>
@@ -5245,7 +5683,7 @@
           <a:p>
             <a:fld id="{2A840DB8-5904-49B0-B377-D22D79484B31}" type="datetimeFigureOut">
               <a:rPr lang="es-CL" smtClean="0"/>
-              <a:t>26-10-2026</a:t>
+              <a:t>27-10-2026</a:t>
             </a:fld>
             <a:endParaRPr lang="es-CL"/>
           </a:p>
@@ -5653,7 +6091,7 @@
           <a:p>
             <a:fld id="{2A840DB8-5904-49B0-B377-D22D79484B31}" type="datetimeFigureOut">
               <a:rPr lang="es-CL" smtClean="0"/>
-              <a:t>26-10-2026</a:t>
+              <a:t>27-10-2026</a:t>
             </a:fld>
             <a:endParaRPr lang="es-CL"/>
           </a:p>
@@ -6004,7 +6442,7 @@
           <a:p>
             <a:fld id="{2A840DB8-5904-49B0-B377-D22D79484B31}" type="datetimeFigureOut">
               <a:rPr lang="es-CL" smtClean="0"/>
-              <a:t>26-10-2026</a:t>
+              <a:t>27-10-2026</a:t>
             </a:fld>
             <a:endParaRPr lang="es-CL"/>
           </a:p>
@@ -6368,7 +6806,7 @@
           <a:p>
             <a:fld id="{2A840DB8-5904-49B0-B377-D22D79484B31}" type="datetimeFigureOut">
               <a:rPr lang="es-CL" smtClean="0"/>
-              <a:t>26-10-2026</a:t>
+              <a:t>27-10-2026</a:t>
             </a:fld>
             <a:endParaRPr lang="es-CL"/>
           </a:p>
@@ -6793,7 +7231,7 @@
           <a:p>
             <a:fld id="{2A840DB8-5904-49B0-B377-D22D79484B31}" type="datetimeFigureOut">
               <a:rPr lang="es-CL" smtClean="0"/>
-              <a:t>26-10-2026</a:t>
+              <a:t>27-10-2026</a:t>
             </a:fld>
             <a:endParaRPr lang="es-CL"/>
           </a:p>
@@ -7376,7 +7814,7 @@
           <a:p>
             <a:fld id="{2A840DB8-5904-49B0-B377-D22D79484B31}" type="datetimeFigureOut">
               <a:rPr lang="es-CL" smtClean="0"/>
-              <a:t>26-10-2026</a:t>
+              <a:t>27-10-2026</a:t>
             </a:fld>
             <a:endParaRPr lang="es-CL"/>
           </a:p>
@@ -7678,7 +8116,7 @@
           <a:p>
             <a:fld id="{2A840DB8-5904-49B0-B377-D22D79484B31}" type="datetimeFigureOut">
               <a:rPr lang="es-CL" smtClean="0"/>
-              <a:t>26-10-2026</a:t>
+              <a:t>27-10-2026</a:t>
             </a:fld>
             <a:endParaRPr lang="es-CL"/>
           </a:p>
@@ -7930,7 +8368,7 @@
           <a:p>
             <a:fld id="{2A840DB8-5904-49B0-B377-D22D79484B31}" type="datetimeFigureOut">
               <a:rPr lang="es-CL" smtClean="0"/>
-              <a:t>26-10-2026</a:t>
+              <a:t>27-10-2026</a:t>
             </a:fld>
             <a:endParaRPr lang="es-CL"/>
           </a:p>
@@ -8242,7 +8680,7 @@
           <a:p>
             <a:fld id="{2A840DB8-5904-49B0-B377-D22D79484B31}" type="datetimeFigureOut">
               <a:rPr lang="es-CL" smtClean="0"/>
-              <a:t>26-10-2026</a:t>
+              <a:t>27-10-2026</a:t>
             </a:fld>
             <a:endParaRPr lang="es-CL"/>
           </a:p>
@@ -8685,7 +9123,7 @@
           <a:p>
             <a:fld id="{2A840DB8-5904-49B0-B377-D22D79484B31}" type="datetimeFigureOut">
               <a:rPr lang="es-CL" smtClean="0"/>
-              <a:t>26-10-2026</a:t>
+              <a:t>27-10-2026</a:t>
             </a:fld>
             <a:endParaRPr lang="es-CL"/>
           </a:p>
@@ -9104,7 +9542,7 @@
           <a:p>
             <a:fld id="{2A840DB8-5904-49B0-B377-D22D79484B31}" type="datetimeFigureOut">
               <a:rPr lang="es-CL" smtClean="0"/>
-              <a:t>26-10-2026</a:t>
+              <a:t>27-10-2026</a:t>
             </a:fld>
             <a:endParaRPr lang="es-CL"/>
           </a:p>
@@ -9509,7 +9947,7 @@
           <a:p>
             <a:fld id="{2A840DB8-5904-49B0-B377-D22D79484B31}" type="datetimeFigureOut">
               <a:rPr lang="es-CL" smtClean="0"/>
-              <a:t>26-10-2026</a:t>
+              <a:t>27-10-2026</a:t>
             </a:fld>
             <a:endParaRPr lang="es-CL"/>
           </a:p>
@@ -9796,7 +10234,7 @@
           <a:p>
             <a:fld id="{2A840DB8-5904-49B0-B377-D22D79484B31}" type="datetimeFigureOut">
               <a:rPr lang="es-CL" smtClean="0"/>
-              <a:t>26-10-2026</a:t>
+              <a:t>27-10-2026</a:t>
             </a:fld>
             <a:endParaRPr lang="es-CL"/>
           </a:p>
@@ -10306,7 +10744,7 @@
           <a:p>
             <a:fld id="{2A840DB8-5904-49B0-B377-D22D79484B31}" type="datetimeFigureOut">
               <a:rPr lang="es-CL" smtClean="0"/>
-              <a:t>26-10-2026</a:t>
+              <a:t>27-10-2026</a:t>
             </a:fld>
             <a:endParaRPr lang="es-CL"/>
           </a:p>
@@ -10723,7 +11161,7 @@
           <a:p>
             <a:fld id="{2A840DB8-5904-49B0-B377-D22D79484B31}" type="datetimeFigureOut">
               <a:rPr lang="es-CL" smtClean="0"/>
-              <a:t>26-10-2026</a:t>
+              <a:t>27-10-2026</a:t>
             </a:fld>
             <a:endParaRPr lang="es-CL"/>
           </a:p>
@@ -11032,7 +11470,7 @@
           <a:p>
             <a:fld id="{2A840DB8-5904-49B0-B377-D22D79484B31}" type="datetimeFigureOut">
               <a:rPr lang="es-CL" smtClean="0"/>
-              <a:t>26-10-2026</a:t>
+              <a:t>27-10-2026</a:t>
             </a:fld>
             <a:endParaRPr lang="es-CL"/>
           </a:p>
@@ -11395,7 +11833,7 @@
           <a:p>
             <a:fld id="{2A840DB8-5904-49B0-B377-D22D79484B31}" type="datetimeFigureOut">
               <a:rPr lang="es-CL" smtClean="0"/>
-              <a:t>26-10-2026</a:t>
+              <a:t>27-10-2026</a:t>
             </a:fld>
             <a:endParaRPr lang="es-CL"/>
           </a:p>
@@ -11768,7 +12206,7 @@
           <a:p>
             <a:fld id="{2A840DB8-5904-49B0-B377-D22D79484B31}" type="datetimeFigureOut">
               <a:rPr lang="es-CL" smtClean="0"/>
-              <a:t>26-10-2026</a:t>
+              <a:t>27-10-2026</a:t>
             </a:fld>
             <a:endParaRPr lang="es-CL"/>
           </a:p>
@@ -12257,10 +12695,15 @@
             <p:ph type="subTitle" idx="1"/>
           </p:nvPr>
         </p:nvSpPr>
-        <p:spPr/>
+        <p:spPr>
+          <a:xfrm>
+            <a:off x="3462963" y="4869029"/>
+            <a:ext cx="7152030" cy="1276131"/>
+          </a:xfrm>
+        </p:spPr>
         <p:txBody>
           <a:bodyPr>
-            <a:normAutofit fontScale="92500" lnSpcReduction="20000"/>
+            <a:normAutofit fontScale="85000" lnSpcReduction="20000"/>
           </a:bodyPr>
           <a:lstStyle/>
           <a:p>
@@ -12281,8 +12724,80 @@
               <a:t>UNAB</a:t>
             </a:r>
           </a:p>
-        </p:txBody>
-      </p:sp>
+          <a:p>
+            <a:r>
+              <a:rPr lang="es-CL" dirty="0"/>
+              <a:t>Practica 2</a:t>
+            </a:r>
+          </a:p>
+        </p:txBody>
+      </p:sp>
+      <p:pic>
+        <p:nvPicPr>
+          <p:cNvPr id="5" name="Imagen 4">
+            <a:extLst>
+              <a:ext uri="{FF2B5EF4-FFF2-40B4-BE49-F238E27FC236}">
+                <a16:creationId xmlns:a16="http://schemas.microsoft.com/office/drawing/2014/main" id="{E45C7406-12C1-33AF-98F4-EAEE6C3686E1}"/>
+              </a:ext>
+            </a:extLst>
+          </p:cNvPr>
+          <p:cNvPicPr>
+            <a:picLocks noChangeAspect="1"/>
+          </p:cNvPicPr>
+          <p:nvPr/>
+        </p:nvPicPr>
+        <p:blipFill>
+          <a:blip r:embed="rId2">
+            <a:extLst>
+              <a:ext uri="{28A0092B-C50C-407E-A947-70E740481C1C}">
+                <a14:useLocalDpi xmlns:a14="http://schemas.microsoft.com/office/drawing/2010/main" val="0"/>
+              </a:ext>
+            </a:extLst>
+          </a:blip>
+          <a:stretch>
+            <a:fillRect/>
+          </a:stretch>
+        </p:blipFill>
+        <p:spPr>
+          <a:xfrm>
+            <a:off x="9583809" y="1775969"/>
+            <a:ext cx="2455658" cy="748516"/>
+          </a:xfrm>
+          <a:prstGeom prst="rect">
+            <a:avLst/>
+          </a:prstGeom>
+        </p:spPr>
+      </p:pic>
+      <p:pic>
+        <p:nvPicPr>
+          <p:cNvPr id="6" name="Imagen 5" descr="Inicio - Telesalud Activa Unab | Universidad Andrés Bello">
+            <a:extLst>
+              <a:ext uri="{FF2B5EF4-FFF2-40B4-BE49-F238E27FC236}">
+                <a16:creationId xmlns:a16="http://schemas.microsoft.com/office/drawing/2014/main" id="{8745FE0F-3234-1453-B200-2FA95DB73D8E}"/>
+              </a:ext>
+            </a:extLst>
+          </p:cNvPr>
+          <p:cNvPicPr>
+            <a:picLocks noChangeAspect="1"/>
+          </p:cNvPicPr>
+          <p:nvPr/>
+        </p:nvPicPr>
+        <p:blipFill>
+          <a:blip r:embed="rId3"/>
+          <a:stretch>
+            <a:fillRect/>
+          </a:stretch>
+        </p:blipFill>
+        <p:spPr>
+          <a:xfrm>
+            <a:off x="9762632" y="-132848"/>
+            <a:ext cx="2098011" cy="1961184"/>
+          </a:xfrm>
+          <a:prstGeom prst="rect">
+            <a:avLst/>
+          </a:prstGeom>
+        </p:spPr>
+      </p:pic>
     </p:spTree>
     <p:extLst>
       <p:ext uri="{BB962C8B-B14F-4D97-AF65-F5344CB8AC3E}">
@@ -12318,7 +12833,7 @@
           <p:cNvPr id="2" name="Título 1">
             <a:extLst>
               <a:ext uri="{FF2B5EF4-FFF2-40B4-BE49-F238E27FC236}">
-                <a16:creationId xmlns:a16="http://schemas.microsoft.com/office/drawing/2014/main" id="{EBF8AA78-7859-78D3-BE35-5F8C7798512B}"/>
+                <a16:creationId xmlns:a16="http://schemas.microsoft.com/office/drawing/2014/main" id="{60522010-8600-330B-824C-61D93C716677}"/>
               </a:ext>
             </a:extLst>
           </p:cNvPr>
@@ -12336,7 +12851,7 @@
           <a:p>
             <a:r>
               <a:rPr lang="es-CL" dirty="0"/>
-              <a:t>Otras funciones</a:t>
+              <a:t>Uso paso a paso</a:t>
             </a:r>
           </a:p>
         </p:txBody>
@@ -12346,7 +12861,7 @@
           <p:cNvPr id="3" name="Marcador de contenido 2">
             <a:extLst>
               <a:ext uri="{FF2B5EF4-FFF2-40B4-BE49-F238E27FC236}">
-                <a16:creationId xmlns:a16="http://schemas.microsoft.com/office/drawing/2014/main" id="{81730190-952E-DDF7-4CD2-F87619DA1842}"/>
+                <a16:creationId xmlns:a16="http://schemas.microsoft.com/office/drawing/2014/main" id="{C168B894-749F-5A0C-5994-B22C0CA0E7BC}"/>
               </a:ext>
             </a:extLst>
           </p:cNvPr>
@@ -12359,8 +12874,8 @@
         </p:nvSpPr>
         <p:spPr>
           <a:xfrm>
-            <a:off x="533398" y="1748474"/>
-            <a:ext cx="5011996" cy="4728524"/>
+            <a:off x="533399" y="1748474"/>
+            <a:ext cx="5727408" cy="4728524"/>
           </a:xfrm>
         </p:spPr>
         <p:txBody>
@@ -12376,8 +12891,8 @@
               <a:buNone/>
             </a:pPr>
             <a:r>
-              <a:rPr lang="es-CL" sz="2400" dirty="0"/>
-              <a:t>El programa tiene funciones para actualizar datos, y generar diversas planillas, pero estas están tras una contraseña de administración para evitar que se hagan cambios por accidente </a:t>
+              <a:rPr lang="es-CL" sz="3200" dirty="0"/>
+              <a:t>La tabla principal posee filtros y un buscador por descripción de un material o su código, teniendo fácil acceso a datos de códigos, stock, ubicación y características</a:t>
             </a:r>
           </a:p>
         </p:txBody>
@@ -12387,69 +12902,7 @@
           <p:cNvPr id="5" name="Imagen 4">
             <a:extLst>
               <a:ext uri="{FF2B5EF4-FFF2-40B4-BE49-F238E27FC236}">
-                <a16:creationId xmlns:a16="http://schemas.microsoft.com/office/drawing/2014/main" id="{3F16B501-5459-6B18-1296-3248E6C8133C}"/>
-              </a:ext>
-            </a:extLst>
-          </p:cNvPr>
-          <p:cNvPicPr>
-            <a:picLocks noChangeAspect="1"/>
-          </p:cNvPicPr>
-          <p:nvPr/>
-        </p:nvPicPr>
-        <p:blipFill>
-          <a:blip r:embed="rId2"/>
-          <a:srcRect r="39678"/>
-          <a:stretch>
-            <a:fillRect/>
-          </a:stretch>
-        </p:blipFill>
-        <p:spPr>
-          <a:xfrm>
-            <a:off x="5987845" y="3369714"/>
-            <a:ext cx="6204155" cy="821500"/>
-          </a:xfrm>
-          <a:prstGeom prst="rect">
-            <a:avLst/>
-          </a:prstGeom>
-        </p:spPr>
-      </p:pic>
-      <p:pic>
-        <p:nvPicPr>
-          <p:cNvPr id="7" name="Imagen 6">
-            <a:extLst>
-              <a:ext uri="{FF2B5EF4-FFF2-40B4-BE49-F238E27FC236}">
-                <a16:creationId xmlns:a16="http://schemas.microsoft.com/office/drawing/2014/main" id="{FDD670C5-8AB4-7D97-E6DF-22BE17F59FAB}"/>
-              </a:ext>
-            </a:extLst>
-          </p:cNvPr>
-          <p:cNvPicPr>
-            <a:picLocks noChangeAspect="1"/>
-          </p:cNvPicPr>
-          <p:nvPr/>
-        </p:nvPicPr>
-        <p:blipFill>
-          <a:blip r:embed="rId2"/>
-          <a:srcRect l="59919"/>
-          <a:stretch>
-            <a:fillRect/>
-          </a:stretch>
-        </p:blipFill>
-        <p:spPr>
-          <a:xfrm>
-            <a:off x="6407693" y="4191214"/>
-            <a:ext cx="5364456" cy="1069044"/>
-          </a:xfrm>
-          <a:prstGeom prst="rect">
-            <a:avLst/>
-          </a:prstGeom>
-        </p:spPr>
-      </p:pic>
-      <p:pic>
-        <p:nvPicPr>
-          <p:cNvPr id="9" name="Imagen 8">
-            <a:extLst>
-              <a:ext uri="{FF2B5EF4-FFF2-40B4-BE49-F238E27FC236}">
-                <a16:creationId xmlns:a16="http://schemas.microsoft.com/office/drawing/2014/main" id="{0D7E48D8-CE47-2D72-EE34-F72BB511BB17}"/>
+                <a16:creationId xmlns:a16="http://schemas.microsoft.com/office/drawing/2014/main" id="{75924882-90EB-ADC2-6CF0-82E97E06FC53}"/>
               </a:ext>
             </a:extLst>
           </p:cNvPr>
@@ -12466,8 +12919,8 @@
         </p:blipFill>
         <p:spPr>
           <a:xfrm>
-            <a:off x="7913000" y="2902390"/>
-            <a:ext cx="2353841" cy="467032"/>
+            <a:off x="6260806" y="1820775"/>
+            <a:ext cx="5845047" cy="4656223"/>
           </a:xfrm>
           <a:prstGeom prst="rect">
             <a:avLst/>
@@ -12477,7 +12930,7 @@
     </p:spTree>
     <p:extLst>
       <p:ext uri="{BB962C8B-B14F-4D97-AF65-F5344CB8AC3E}">
-        <p14:creationId xmlns:p14="http://schemas.microsoft.com/office/powerpoint/2010/main" val="437579907"/>
+        <p14:creationId xmlns:p14="http://schemas.microsoft.com/office/powerpoint/2010/main" val="4036243683"/>
       </p:ext>
     </p:extLst>
   </p:cSld>
@@ -12509,7 +12962,7 @@
           <p:cNvPr id="2" name="Título 1">
             <a:extLst>
               <a:ext uri="{FF2B5EF4-FFF2-40B4-BE49-F238E27FC236}">
-                <a16:creationId xmlns:a16="http://schemas.microsoft.com/office/drawing/2014/main" id="{032C29E4-EDD2-66E1-C002-605076F9FF68}"/>
+                <a16:creationId xmlns:a16="http://schemas.microsoft.com/office/drawing/2014/main" id="{EBF8AA78-7859-78D3-BE35-5F8C7798512B}"/>
               </a:ext>
             </a:extLst>
           </p:cNvPr>
@@ -12527,7 +12980,7 @@
           <a:p>
             <a:r>
               <a:rPr lang="es-CL" dirty="0"/>
-              <a:t>Limitaciones</a:t>
+              <a:t>Otras funciones</a:t>
             </a:r>
           </a:p>
         </p:txBody>
@@ -12537,7 +12990,7 @@
           <p:cNvPr id="3" name="Marcador de contenido 2">
             <a:extLst>
               <a:ext uri="{FF2B5EF4-FFF2-40B4-BE49-F238E27FC236}">
-                <a16:creationId xmlns:a16="http://schemas.microsoft.com/office/drawing/2014/main" id="{68444BD3-3B13-BE5B-A21A-66A85B85D068}"/>
+                <a16:creationId xmlns:a16="http://schemas.microsoft.com/office/drawing/2014/main" id="{81730190-952E-DDF7-4CD2-F87619DA1842}"/>
               </a:ext>
             </a:extLst>
           </p:cNvPr>
@@ -12551,7 +13004,7 @@
         <p:spPr>
           <a:xfrm>
             <a:off x="533398" y="1748474"/>
-            <a:ext cx="6260692" cy="4728524"/>
+            <a:ext cx="5011996" cy="4728524"/>
           </a:xfrm>
         </p:spPr>
         <p:txBody>
@@ -12560,46 +13013,25 @@
           </a:bodyPr>
           <a:lstStyle/>
           <a:p>
-            <a:pPr>
+            <a:pPr marL="0" indent="0">
               <a:lnSpc>
                 <a:spcPct val="150000"/>
               </a:lnSpc>
+              <a:buNone/>
             </a:pPr>
             <a:r>
-              <a:rPr lang="es-CL" sz="2800" dirty="0"/>
-              <a:t>Hibernación sin uso</a:t>
-            </a:r>
-          </a:p>
-          <a:p>
-            <a:pPr>
-              <a:lnSpc>
-                <a:spcPct val="150000"/>
-              </a:lnSpc>
-            </a:pPr>
-            <a:r>
-              <a:rPr lang="es-CL" sz="2800" dirty="0"/>
-              <a:t>Bloqueo por desuso</a:t>
-            </a:r>
-          </a:p>
-          <a:p>
-            <a:pPr>
-              <a:lnSpc>
-                <a:spcPct val="150000"/>
-              </a:lnSpc>
-            </a:pPr>
-            <a:r>
-              <a:rPr lang="es-CL" sz="2800" dirty="0"/>
-              <a:t>Limite de peticiones (difícil de llegar)</a:t>
+              <a:rPr lang="es-CL" sz="2400" dirty="0"/>
+              <a:t>El programa tiene funciones para actualizar datos, y generar diversas planillas, pero estas están tras una contraseña de administración para evitar que se hagan cambios por accidente </a:t>
             </a:r>
           </a:p>
         </p:txBody>
       </p:sp>
       <p:pic>
         <p:nvPicPr>
-          <p:cNvPr id="6" name="Imagen 5" descr="gratis muestra ligero azul sello - Clásico circular promocional sello  76534812 PNG">
-            <a:extLst>
-              <a:ext uri="{FF2B5EF4-FFF2-40B4-BE49-F238E27FC236}">
-                <a16:creationId xmlns:a16="http://schemas.microsoft.com/office/drawing/2014/main" id="{409DD116-8C59-2965-2690-70183B0B3AD6}"/>
+          <p:cNvPr id="5" name="Imagen 4">
+            <a:extLst>
+              <a:ext uri="{FF2B5EF4-FFF2-40B4-BE49-F238E27FC236}">
+                <a16:creationId xmlns:a16="http://schemas.microsoft.com/office/drawing/2014/main" id="{3F16B501-5459-6B18-1296-3248E6C8133C}"/>
               </a:ext>
             </a:extLst>
           </p:cNvPr>
@@ -12610,14 +13042,76 @@
         </p:nvPicPr>
         <p:blipFill>
           <a:blip r:embed="rId2"/>
+          <a:srcRect r="39678"/>
           <a:stretch>
             <a:fillRect/>
           </a:stretch>
         </p:blipFill>
         <p:spPr>
           <a:xfrm>
-            <a:off x="6915846" y="1390334"/>
-            <a:ext cx="5147188" cy="5147188"/>
+            <a:off x="5987845" y="3369714"/>
+            <a:ext cx="6204155" cy="821500"/>
+          </a:xfrm>
+          <a:prstGeom prst="rect">
+            <a:avLst/>
+          </a:prstGeom>
+        </p:spPr>
+      </p:pic>
+      <p:pic>
+        <p:nvPicPr>
+          <p:cNvPr id="7" name="Imagen 6">
+            <a:extLst>
+              <a:ext uri="{FF2B5EF4-FFF2-40B4-BE49-F238E27FC236}">
+                <a16:creationId xmlns:a16="http://schemas.microsoft.com/office/drawing/2014/main" id="{FDD670C5-8AB4-7D97-E6DF-22BE17F59FAB}"/>
+              </a:ext>
+            </a:extLst>
+          </p:cNvPr>
+          <p:cNvPicPr>
+            <a:picLocks noChangeAspect="1"/>
+          </p:cNvPicPr>
+          <p:nvPr/>
+        </p:nvPicPr>
+        <p:blipFill>
+          <a:blip r:embed="rId2"/>
+          <a:srcRect l="59919"/>
+          <a:stretch>
+            <a:fillRect/>
+          </a:stretch>
+        </p:blipFill>
+        <p:spPr>
+          <a:xfrm>
+            <a:off x="6407693" y="4191214"/>
+            <a:ext cx="5364456" cy="1069044"/>
+          </a:xfrm>
+          <a:prstGeom prst="rect">
+            <a:avLst/>
+          </a:prstGeom>
+        </p:spPr>
+      </p:pic>
+      <p:pic>
+        <p:nvPicPr>
+          <p:cNvPr id="9" name="Imagen 8">
+            <a:extLst>
+              <a:ext uri="{FF2B5EF4-FFF2-40B4-BE49-F238E27FC236}">
+                <a16:creationId xmlns:a16="http://schemas.microsoft.com/office/drawing/2014/main" id="{0D7E48D8-CE47-2D72-EE34-F72BB511BB17}"/>
+              </a:ext>
+            </a:extLst>
+          </p:cNvPr>
+          <p:cNvPicPr>
+            <a:picLocks noChangeAspect="1"/>
+          </p:cNvPicPr>
+          <p:nvPr/>
+        </p:nvPicPr>
+        <p:blipFill>
+          <a:blip r:embed="rId3"/>
+          <a:stretch>
+            <a:fillRect/>
+          </a:stretch>
+        </p:blipFill>
+        <p:spPr>
+          <a:xfrm>
+            <a:off x="7913000" y="2902390"/>
+            <a:ext cx="2353841" cy="467032"/>
           </a:xfrm>
           <a:prstGeom prst="rect">
             <a:avLst/>
@@ -12627,7 +13121,7 @@
     </p:spTree>
     <p:extLst>
       <p:ext uri="{BB962C8B-B14F-4D97-AF65-F5344CB8AC3E}">
-        <p14:creationId xmlns:p14="http://schemas.microsoft.com/office/powerpoint/2010/main" val="2994872290"/>
+        <p14:creationId xmlns:p14="http://schemas.microsoft.com/office/powerpoint/2010/main" val="437579907"/>
       </p:ext>
     </p:extLst>
   </p:cSld>
@@ -12659,7 +13153,7 @@
           <p:cNvPr id="2" name="Título 1">
             <a:extLst>
               <a:ext uri="{FF2B5EF4-FFF2-40B4-BE49-F238E27FC236}">
-                <a16:creationId xmlns:a16="http://schemas.microsoft.com/office/drawing/2014/main" id="{0E7C8785-EBB3-2A39-D6BF-0F6A8C1CB828}"/>
+                <a16:creationId xmlns:a16="http://schemas.microsoft.com/office/drawing/2014/main" id="{032C29E4-EDD2-66E1-C002-605076F9FF68}"/>
               </a:ext>
             </a:extLst>
           </p:cNvPr>
@@ -12677,7 +13171,7 @@
           <a:p>
             <a:r>
               <a:rPr lang="es-CL" dirty="0"/>
-              <a:t>Dudas y recomendaciones</a:t>
+              <a:t>Limitaciones</a:t>
             </a:r>
           </a:p>
         </p:txBody>
@@ -12687,7 +13181,7 @@
           <p:cNvPr id="3" name="Marcador de contenido 2">
             <a:extLst>
               <a:ext uri="{FF2B5EF4-FFF2-40B4-BE49-F238E27FC236}">
-                <a16:creationId xmlns:a16="http://schemas.microsoft.com/office/drawing/2014/main" id="{707DA998-C715-FDE5-BD7E-D5B16B590EA1}"/>
+                <a16:creationId xmlns:a16="http://schemas.microsoft.com/office/drawing/2014/main" id="{68444BD3-3B13-BE5B-A21A-66A85B85D068}"/>
               </a:ext>
             </a:extLst>
           </p:cNvPr>
@@ -12701,7 +13195,7 @@
         <p:spPr>
           <a:xfrm>
             <a:off x="533398" y="1748474"/>
-            <a:ext cx="6948950" cy="4728524"/>
+            <a:ext cx="6260692" cy="4728524"/>
           </a:xfrm>
         </p:spPr>
         <p:txBody>
@@ -12716,8 +13210,8 @@
               </a:lnSpc>
             </a:pPr>
             <a:r>
-              <a:rPr lang="es-CL" sz="2400" dirty="0"/>
-              <a:t>Se responderán todas las dudas sobre el programa</a:t>
+              <a:rPr lang="es-CL" sz="2800" dirty="0"/>
+              <a:t>Hibernación sin uso</a:t>
             </a:r>
           </a:p>
           <a:p>
@@ -12727,8 +13221,8 @@
               </a:lnSpc>
             </a:pPr>
             <a:r>
-              <a:rPr lang="es-CL" sz="2400" dirty="0"/>
-              <a:t>Se aceptaran y evaluaran las recomendaciones para el programa</a:t>
+              <a:rPr lang="es-CL" sz="2800" dirty="0"/>
+              <a:t>Bloqueo por desuso</a:t>
             </a:r>
           </a:p>
           <a:p>
@@ -12738,6 +13232,156 @@
               </a:lnSpc>
             </a:pPr>
             <a:r>
+              <a:rPr lang="es-CL" sz="2800" dirty="0"/>
+              <a:t>Limite de peticiones (difícil de llegar)</a:t>
+            </a:r>
+          </a:p>
+        </p:txBody>
+      </p:sp>
+      <p:pic>
+        <p:nvPicPr>
+          <p:cNvPr id="4" name="Imagen 3" descr="Gratis">
+            <a:extLst>
+              <a:ext uri="{FF2B5EF4-FFF2-40B4-BE49-F238E27FC236}">
+                <a16:creationId xmlns:a16="http://schemas.microsoft.com/office/drawing/2014/main" id="{320E724C-D988-504A-583F-6CE5C70FE9C8}"/>
+              </a:ext>
+            </a:extLst>
+          </p:cNvPr>
+          <p:cNvPicPr>
+            <a:picLocks noChangeAspect="1"/>
+          </p:cNvPicPr>
+          <p:nvPr/>
+        </p:nvPicPr>
+        <p:blipFill>
+          <a:blip r:embed="rId2"/>
+          <a:stretch>
+            <a:fillRect/>
+          </a:stretch>
+        </p:blipFill>
+        <p:spPr>
+          <a:xfrm>
+            <a:off x="6951406" y="1699491"/>
+            <a:ext cx="4836240" cy="4826490"/>
+          </a:xfrm>
+          <a:prstGeom prst="rect">
+            <a:avLst/>
+          </a:prstGeom>
+        </p:spPr>
+      </p:pic>
+    </p:spTree>
+    <p:extLst>
+      <p:ext uri="{BB962C8B-B14F-4D97-AF65-F5344CB8AC3E}">
+        <p14:creationId xmlns:p14="http://schemas.microsoft.com/office/powerpoint/2010/main" val="2994872290"/>
+      </p:ext>
+    </p:extLst>
+  </p:cSld>
+  <p:clrMapOvr>
+    <a:masterClrMapping/>
+  </p:clrMapOvr>
+</p:sld>
+</file>
+
+<file path=ppt/slides/slide13.xml><?xml version="1.0" encoding="utf-8"?>
+<p:sld xmlns:a="http://schemas.openxmlformats.org/drawingml/2006/main" xmlns:r="http://schemas.openxmlformats.org/officeDocument/2006/relationships" xmlns:p="http://schemas.openxmlformats.org/presentationml/2006/main">
+  <p:cSld>
+    <p:spTree>
+      <p:nvGrpSpPr>
+        <p:cNvPr id="1" name=""/>
+        <p:cNvGrpSpPr/>
+        <p:nvPr/>
+      </p:nvGrpSpPr>
+      <p:grpSpPr>
+        <a:xfrm>
+          <a:off x="0" y="0"/>
+          <a:ext cx="0" cy="0"/>
+          <a:chOff x="0" y="0"/>
+          <a:chExt cx="0" cy="0"/>
+        </a:xfrm>
+      </p:grpSpPr>
+      <p:sp>
+        <p:nvSpPr>
+          <p:cNvPr id="2" name="Título 1">
+            <a:extLst>
+              <a:ext uri="{FF2B5EF4-FFF2-40B4-BE49-F238E27FC236}">
+                <a16:creationId xmlns:a16="http://schemas.microsoft.com/office/drawing/2014/main" id="{0E7C8785-EBB3-2A39-D6BF-0F6A8C1CB828}"/>
+              </a:ext>
+            </a:extLst>
+          </p:cNvPr>
+          <p:cNvSpPr>
+            <a:spLocks noGrp="1"/>
+          </p:cNvSpPr>
+          <p:nvPr>
+            <p:ph type="title"/>
+          </p:nvPr>
+        </p:nvSpPr>
+        <p:spPr/>
+        <p:txBody>
+          <a:bodyPr/>
+          <a:lstStyle/>
+          <a:p>
+            <a:r>
+              <a:rPr lang="es-CL" dirty="0"/>
+              <a:t>Dudas y recomendaciones</a:t>
+            </a:r>
+          </a:p>
+        </p:txBody>
+      </p:sp>
+      <p:sp>
+        <p:nvSpPr>
+          <p:cNvPr id="3" name="Marcador de contenido 2">
+            <a:extLst>
+              <a:ext uri="{FF2B5EF4-FFF2-40B4-BE49-F238E27FC236}">
+                <a16:creationId xmlns:a16="http://schemas.microsoft.com/office/drawing/2014/main" id="{707DA998-C715-FDE5-BD7E-D5B16B590EA1}"/>
+              </a:ext>
+            </a:extLst>
+          </p:cNvPr>
+          <p:cNvSpPr>
+            <a:spLocks noGrp="1"/>
+          </p:cNvSpPr>
+          <p:nvPr>
+            <p:ph idx="1"/>
+          </p:nvPr>
+        </p:nvSpPr>
+        <p:spPr>
+          <a:xfrm>
+            <a:off x="533398" y="1748474"/>
+            <a:ext cx="6948950" cy="4728524"/>
+          </a:xfrm>
+        </p:spPr>
+        <p:txBody>
+          <a:bodyPr anchor="ctr">
+            <a:normAutofit/>
+          </a:bodyPr>
+          <a:lstStyle/>
+          <a:p>
+            <a:pPr>
+              <a:lnSpc>
+                <a:spcPct val="150000"/>
+              </a:lnSpc>
+            </a:pPr>
+            <a:r>
+              <a:rPr lang="es-CL" sz="2400" dirty="0"/>
+              <a:t>Se responderán todas las dudas sobre el programa</a:t>
+            </a:r>
+          </a:p>
+          <a:p>
+            <a:pPr>
+              <a:lnSpc>
+                <a:spcPct val="150000"/>
+              </a:lnSpc>
+            </a:pPr>
+            <a:r>
+              <a:rPr lang="es-CL" sz="2400" dirty="0"/>
+              <a:t>Se aceptaran y evaluaran las recomendaciones para el programa</a:t>
+            </a:r>
+          </a:p>
+          <a:p>
+            <a:pPr>
+              <a:lnSpc>
+                <a:spcPct val="150000"/>
+              </a:lnSpc>
+            </a:pPr>
+            <a:r>
               <a:rPr lang="es-CL" sz="2400" dirty="0"/>
               <a:t>Se puede consultar el manual de uso para el programa</a:t>
             </a:r>
@@ -12746,10 +13390,10 @@
       </p:sp>
       <p:pic>
         <p:nvPicPr>
-          <p:cNvPr id="5" name="Imagen 4">
-            <a:extLst>
-              <a:ext uri="{FF2B5EF4-FFF2-40B4-BE49-F238E27FC236}">
-                <a16:creationId xmlns:a16="http://schemas.microsoft.com/office/drawing/2014/main" id="{9842A99B-2500-8215-D124-C9F74C7736F6}"/>
+          <p:cNvPr id="6" name="Imagen 5">
+            <a:extLst>
+              <a:ext uri="{FF2B5EF4-FFF2-40B4-BE49-F238E27FC236}">
+                <a16:creationId xmlns:a16="http://schemas.microsoft.com/office/drawing/2014/main" id="{387862F6-DA86-EC80-E2E9-5AC677C84D10}"/>
               </a:ext>
             </a:extLst>
           </p:cNvPr>
@@ -12772,8 +13416,8 @@
         </p:blipFill>
         <p:spPr>
           <a:xfrm>
-            <a:off x="7806812" y="2186842"/>
-            <a:ext cx="3851787" cy="3851787"/>
+            <a:off x="8003457" y="2234774"/>
+            <a:ext cx="3755924" cy="3755924"/>
           </a:xfrm>
           <a:prstGeom prst="rect">
             <a:avLst/>
@@ -12862,7 +13506,7 @@
         </p:spPr>
         <p:txBody>
           <a:bodyPr anchor="ctr">
-            <a:normAutofit fontScale="92500" lnSpcReduction="10000"/>
+            <a:normAutofit fontScale="85000" lnSpcReduction="20000"/>
           </a:bodyPr>
           <a:lstStyle/>
           <a:p>
@@ -12895,7 +13539,7 @@
             </a:pPr>
             <a:r>
               <a:rPr lang="es-CL" sz="3200" dirty="0"/>
-              <a:t>Uso paso a paso</a:t>
+              <a:t>Avisos</a:t>
             </a:r>
           </a:p>
           <a:p>
@@ -12906,7 +13550,7 @@
             </a:pPr>
             <a:r>
               <a:rPr lang="es-CL" sz="3200" dirty="0"/>
-              <a:t>Otras funciones</a:t>
+              <a:t>Uso paso a paso</a:t>
             </a:r>
           </a:p>
           <a:p>
@@ -12917,7 +13561,7 @@
             </a:pPr>
             <a:r>
               <a:rPr lang="es-CL" sz="3200" dirty="0"/>
-              <a:t>Limitaciones</a:t>
+              <a:t>Otras funciones</a:t>
             </a:r>
           </a:p>
           <a:p>
@@ -12928,11 +13572,52 @@
             </a:pPr>
             <a:r>
               <a:rPr lang="es-CL" sz="3200" dirty="0"/>
+              <a:t>Limitaciones</a:t>
+            </a:r>
+          </a:p>
+          <a:p>
+            <a:pPr>
+              <a:lnSpc>
+                <a:spcPct val="150000"/>
+              </a:lnSpc>
+            </a:pPr>
+            <a:r>
+              <a:rPr lang="es-CL" sz="3200" dirty="0"/>
               <a:t>Dudas y recomendaciones</a:t>
             </a:r>
           </a:p>
         </p:txBody>
       </p:sp>
+      <p:pic>
+        <p:nvPicPr>
+          <p:cNvPr id="4" name="Imagen 3" descr="Hoja de Ruta">
+            <a:extLst>
+              <a:ext uri="{FF2B5EF4-FFF2-40B4-BE49-F238E27FC236}">
+                <a16:creationId xmlns:a16="http://schemas.microsoft.com/office/drawing/2014/main" id="{CB145906-BA0E-6D98-6DE7-8243D9160FB6}"/>
+              </a:ext>
+            </a:extLst>
+          </p:cNvPr>
+          <p:cNvPicPr>
+            <a:picLocks noChangeAspect="1"/>
+          </p:cNvPicPr>
+          <p:nvPr/>
+        </p:nvPicPr>
+        <p:blipFill>
+          <a:blip r:embed="rId2"/>
+          <a:stretch>
+            <a:fillRect/>
+          </a:stretch>
+        </p:blipFill>
+        <p:spPr>
+          <a:xfrm>
+            <a:off x="6095998" y="1763714"/>
+            <a:ext cx="5841270" cy="3898413"/>
+          </a:xfrm>
+          <a:prstGeom prst="rect">
+            <a:avLst/>
+          </a:prstGeom>
+        </p:spPr>
+      </p:pic>
     </p:spTree>
     <p:extLst>
       <p:ext uri="{BB962C8B-B14F-4D97-AF65-F5344CB8AC3E}">
@@ -13007,10 +13692,15 @@
             <p:ph idx="1"/>
           </p:nvPr>
         </p:nvSpPr>
-        <p:spPr/>
+        <p:spPr>
+          <a:xfrm>
+            <a:off x="533399" y="1748474"/>
+            <a:ext cx="6309853" cy="4728524"/>
+          </a:xfrm>
+        </p:spPr>
         <p:txBody>
           <a:bodyPr anchor="ctr">
-            <a:normAutofit/>
+            <a:normAutofit fontScale="92500" lnSpcReduction="20000"/>
           </a:bodyPr>
           <a:lstStyle/>
           <a:p>
@@ -13048,6 +13738,36 @@
           </a:p>
         </p:txBody>
       </p:sp>
+      <p:pic>
+        <p:nvPicPr>
+          <p:cNvPr id="4" name="Imagen 3" descr="5 ventajas de tener un buen control de inventarios | Defontana Chile">
+            <a:extLst>
+              <a:ext uri="{FF2B5EF4-FFF2-40B4-BE49-F238E27FC236}">
+                <a16:creationId xmlns:a16="http://schemas.microsoft.com/office/drawing/2014/main" id="{9FCCF693-ED24-80B9-23B7-4CBDFBA1CBE9}"/>
+              </a:ext>
+            </a:extLst>
+          </p:cNvPr>
+          <p:cNvPicPr>
+            <a:picLocks noChangeAspect="1"/>
+          </p:cNvPicPr>
+          <p:nvPr/>
+        </p:nvPicPr>
+        <p:blipFill>
+          <a:blip r:embed="rId2"/>
+          <a:stretch>
+            <a:fillRect/>
+          </a:stretch>
+        </p:blipFill>
+        <p:spPr>
+          <a:xfrm>
+            <a:off x="6567948" y="2495233"/>
+            <a:ext cx="5707626" cy="3017907"/>
+          </a:xfrm>
+          <a:prstGeom prst="rect">
+            <a:avLst/>
+          </a:prstGeom>
+        </p:spPr>
+      </p:pic>
     </p:spTree>
     <p:extLst>
       <p:ext uri="{BB962C8B-B14F-4D97-AF65-F5344CB8AC3E}">
@@ -13135,8 +13855,8 @@
         </p:blipFill>
         <p:spPr>
           <a:xfrm>
-            <a:off x="0" y="1778792"/>
-            <a:ext cx="4400554" cy="3300415"/>
+            <a:off x="0" y="230212"/>
+            <a:ext cx="4265051" cy="3198788"/>
           </a:xfrm>
           <a:prstGeom prst="rect">
             <a:avLst/>
@@ -13226,6 +13946,36 @@
           </a:p>
         </p:txBody>
       </p:sp>
+      <p:pic>
+        <p:nvPicPr>
+          <p:cNvPr id="4" name="Imagen 3" descr="Diseño PNG Y SVG De Smartphone En Dibujos Animados De Mano Para Camisetas">
+            <a:extLst>
+              <a:ext uri="{FF2B5EF4-FFF2-40B4-BE49-F238E27FC236}">
+                <a16:creationId xmlns:a16="http://schemas.microsoft.com/office/drawing/2014/main" id="{773F5142-AEE6-4ACE-B8ED-36D34BC8C78C}"/>
+              </a:ext>
+            </a:extLst>
+          </p:cNvPr>
+          <p:cNvPicPr>
+            <a:picLocks noChangeAspect="1"/>
+          </p:cNvPicPr>
+          <p:nvPr/>
+        </p:nvPicPr>
+        <p:blipFill>
+          <a:blip r:embed="rId3"/>
+          <a:stretch>
+            <a:fillRect/>
+          </a:stretch>
+        </p:blipFill>
+        <p:spPr>
+          <a:xfrm>
+            <a:off x="135502" y="2886089"/>
+            <a:ext cx="4129549" cy="4129549"/>
+          </a:xfrm>
+          <a:prstGeom prst="rect">
+            <a:avLst/>
+          </a:prstGeom>
+        </p:spPr>
+      </p:pic>
     </p:spTree>
     <p:extLst>
       <p:ext uri="{BB962C8B-B14F-4D97-AF65-F5344CB8AC3E}">
@@ -13261,7 +14011,7 @@
           <p:cNvPr id="2" name="Título 1">
             <a:extLst>
               <a:ext uri="{FF2B5EF4-FFF2-40B4-BE49-F238E27FC236}">
-                <a16:creationId xmlns:a16="http://schemas.microsoft.com/office/drawing/2014/main" id="{1AE1EA89-5485-4AF0-BFF9-FD88860FF2AB}"/>
+                <a16:creationId xmlns:a16="http://schemas.microsoft.com/office/drawing/2014/main" id="{BD85CB2D-8012-B639-0AFB-CF3F841F3E54}"/>
               </a:ext>
             </a:extLst>
           </p:cNvPr>
@@ -13279,7 +14029,7 @@
           <a:p>
             <a:r>
               <a:rPr lang="es-CL" dirty="0"/>
-              <a:t>Uso paso a paso</a:t>
+              <a:t>Avisos</a:t>
             </a:r>
           </a:p>
         </p:txBody>
@@ -13289,7 +14039,7 @@
           <p:cNvPr id="3" name="Marcador de contenido 2">
             <a:extLst>
               <a:ext uri="{FF2B5EF4-FFF2-40B4-BE49-F238E27FC236}">
-                <a16:creationId xmlns:a16="http://schemas.microsoft.com/office/drawing/2014/main" id="{B5BDF2B4-F218-D6F0-A899-E243A8177847}"/>
+                <a16:creationId xmlns:a16="http://schemas.microsoft.com/office/drawing/2014/main" id="{97CE68D5-166C-9D73-3044-5FD4AA783691}"/>
               </a:ext>
             </a:extLst>
           </p:cNvPr>
@@ -13303,12 +14053,12 @@
         <p:spPr>
           <a:xfrm>
             <a:off x="533398" y="1748474"/>
-            <a:ext cx="6811299" cy="4728524"/>
+            <a:ext cx="7007944" cy="4728524"/>
           </a:xfrm>
         </p:spPr>
         <p:txBody>
           <a:bodyPr anchor="ctr">
-            <a:normAutofit/>
+            <a:normAutofit fontScale="77500" lnSpcReduction="20000"/>
           </a:bodyPr>
           <a:lstStyle/>
           <a:p>
@@ -13318,8 +14068,8 @@
               </a:lnSpc>
             </a:pPr>
             <a:r>
-              <a:rPr lang="es-CL" sz="2400" dirty="0"/>
-              <a:t>Tener una cuenta proporcionada por el personal de oficina</a:t>
+              <a:rPr lang="es-CL" sz="2800" dirty="0"/>
+              <a:t>Eso es una web, no una APP</a:t>
             </a:r>
           </a:p>
           <a:p>
@@ -13329,8 +14079,8 @@
               </a:lnSpc>
             </a:pPr>
             <a:r>
-              <a:rPr lang="es-CL" sz="2400" dirty="0"/>
-              <a:t>QR para cada material</a:t>
+              <a:rPr lang="es-CL" sz="2800" dirty="0"/>
+              <a:t>La velocidad del programa dependerá de la conexión, apenas afecta el tipo de dispositivo</a:t>
             </a:r>
           </a:p>
           <a:p>
@@ -13340,18 +14090,40 @@
               </a:lnSpc>
             </a:pPr>
             <a:r>
-              <a:rPr lang="es-CL" sz="2400" dirty="0"/>
-              <a:t>Escanear QR con tu teléfono</a:t>
+              <a:rPr lang="es-CL" sz="2800" dirty="0"/>
+              <a:t>Solo tiene acceso el personal de bodega, no debería de tener acceso externos</a:t>
+            </a:r>
+          </a:p>
+          <a:p>
+            <a:pPr>
+              <a:lnSpc>
+                <a:spcPct val="150000"/>
+              </a:lnSpc>
+            </a:pPr>
+            <a:r>
+              <a:rPr lang="es-CL" sz="2800" dirty="0"/>
+              <a:t>Esto es una herramienta de ayuda, no de reemplazo</a:t>
+            </a:r>
+          </a:p>
+          <a:p>
+            <a:pPr>
+              <a:lnSpc>
+                <a:spcPct val="150000"/>
+              </a:lnSpc>
+            </a:pPr>
+            <a:r>
+              <a:rPr lang="es-CL" sz="2800" dirty="0"/>
+              <a:t>No habrá un costo agregado al uso del programa</a:t>
             </a:r>
           </a:p>
         </p:txBody>
       </p:sp>
       <p:pic>
         <p:nvPicPr>
-          <p:cNvPr id="5" name="Imagen 4">
-            <a:extLst>
-              <a:ext uri="{FF2B5EF4-FFF2-40B4-BE49-F238E27FC236}">
-                <a16:creationId xmlns:a16="http://schemas.microsoft.com/office/drawing/2014/main" id="{896BAA3E-31CE-CE1B-DE09-9805C48A494A}"/>
+          <p:cNvPr id="4" name="Imagen 3" descr="Descarga iconos gratuitos de Aviso en PNG y SVG | Magnific (antes Freepik)">
+            <a:extLst>
+              <a:ext uri="{FF2B5EF4-FFF2-40B4-BE49-F238E27FC236}">
+                <a16:creationId xmlns:a16="http://schemas.microsoft.com/office/drawing/2014/main" id="{ADC22296-763E-71AD-B9C1-35979D9E04C0}"/>
               </a:ext>
             </a:extLst>
           </p:cNvPr>
@@ -13368,8 +14140,8 @@
         </p:blipFill>
         <p:spPr>
           <a:xfrm>
-            <a:off x="7604408" y="2123743"/>
-            <a:ext cx="4054191" cy="3977985"/>
+            <a:off x="7782475" y="1907973"/>
+            <a:ext cx="4409525" cy="4409525"/>
           </a:xfrm>
           <a:prstGeom prst="rect">
             <a:avLst/>
@@ -13379,7 +14151,7 @@
     </p:spTree>
     <p:extLst>
       <p:ext uri="{BB962C8B-B14F-4D97-AF65-F5344CB8AC3E}">
-        <p14:creationId xmlns:p14="http://schemas.microsoft.com/office/powerpoint/2010/main" val="3763785385"/>
+        <p14:creationId xmlns:p14="http://schemas.microsoft.com/office/powerpoint/2010/main" val="3790201464"/>
       </p:ext>
     </p:extLst>
   </p:cSld>
@@ -13411,7 +14183,7 @@
           <p:cNvPr id="2" name="Título 1">
             <a:extLst>
               <a:ext uri="{FF2B5EF4-FFF2-40B4-BE49-F238E27FC236}">
-                <a16:creationId xmlns:a16="http://schemas.microsoft.com/office/drawing/2014/main" id="{663373FA-900C-90C5-5A16-9998A7DC7439}"/>
+                <a16:creationId xmlns:a16="http://schemas.microsoft.com/office/drawing/2014/main" id="{1AE1EA89-5485-4AF0-BFF9-FD88860FF2AB}"/>
               </a:ext>
             </a:extLst>
           </p:cNvPr>
@@ -13439,7 +14211,7 @@
           <p:cNvPr id="3" name="Marcador de contenido 2">
             <a:extLst>
               <a:ext uri="{FF2B5EF4-FFF2-40B4-BE49-F238E27FC236}">
-                <a16:creationId xmlns:a16="http://schemas.microsoft.com/office/drawing/2014/main" id="{394509AB-D573-D458-283A-569872D9C6EF}"/>
+                <a16:creationId xmlns:a16="http://schemas.microsoft.com/office/drawing/2014/main" id="{B5BDF2B4-F218-D6F0-A899-E243A8177847}"/>
               </a:ext>
             </a:extLst>
           </p:cNvPr>
@@ -13453,7 +14225,7 @@
         <p:spPr>
           <a:xfrm>
             <a:off x="533398" y="1748474"/>
-            <a:ext cx="5149647" cy="4728524"/>
+            <a:ext cx="6811299" cy="4728524"/>
           </a:xfrm>
         </p:spPr>
         <p:txBody>
@@ -13462,15 +14234,36 @@
           </a:bodyPr>
           <a:lstStyle/>
           <a:p>
-            <a:pPr marL="0" indent="0">
+            <a:pPr>
               <a:lnSpc>
                 <a:spcPct val="150000"/>
               </a:lnSpc>
-              <a:buNone/>
             </a:pPr>
             <a:r>
-              <a:rPr lang="es-CL" sz="3200" dirty="0"/>
-              <a:t>Una vez con la sesión iniciada y el QR escaneado aparecerá la siguiente pagina</a:t>
+              <a:rPr lang="es-CL" sz="2400" dirty="0"/>
+              <a:t>Tener una cuenta proporcionada por el personal de oficina</a:t>
+            </a:r>
+          </a:p>
+          <a:p>
+            <a:pPr>
+              <a:lnSpc>
+                <a:spcPct val="150000"/>
+              </a:lnSpc>
+            </a:pPr>
+            <a:r>
+              <a:rPr lang="es-CL" sz="2400" dirty="0"/>
+              <a:t>QR para cada material</a:t>
+            </a:r>
+          </a:p>
+          <a:p>
+            <a:pPr>
+              <a:lnSpc>
+                <a:spcPct val="150000"/>
+              </a:lnSpc>
+            </a:pPr>
+            <a:r>
+              <a:rPr lang="es-CL" sz="2400" dirty="0"/>
+              <a:t>Escanear QR con tu teléfono</a:t>
             </a:r>
           </a:p>
         </p:txBody>
@@ -13480,7 +14273,7 @@
           <p:cNvPr id="5" name="Imagen 4">
             <a:extLst>
               <a:ext uri="{FF2B5EF4-FFF2-40B4-BE49-F238E27FC236}">
-                <a16:creationId xmlns:a16="http://schemas.microsoft.com/office/drawing/2014/main" id="{B4EE2941-3D2A-1E80-096E-FC917543F9FC}"/>
+                <a16:creationId xmlns:a16="http://schemas.microsoft.com/office/drawing/2014/main" id="{896BAA3E-31CE-CE1B-DE09-9805C48A494A}"/>
               </a:ext>
             </a:extLst>
           </p:cNvPr>
@@ -13497,8 +14290,8 @@
         </p:blipFill>
         <p:spPr>
           <a:xfrm>
-            <a:off x="8382254" y="1495039"/>
-            <a:ext cx="2644369" cy="5235394"/>
+            <a:off x="7604408" y="2123743"/>
+            <a:ext cx="4054191" cy="3977985"/>
           </a:xfrm>
           <a:prstGeom prst="rect">
             <a:avLst/>
@@ -13508,7 +14301,7 @@
     </p:spTree>
     <p:extLst>
       <p:ext uri="{BB962C8B-B14F-4D97-AF65-F5344CB8AC3E}">
-        <p14:creationId xmlns:p14="http://schemas.microsoft.com/office/powerpoint/2010/main" val="2754568070"/>
+        <p14:creationId xmlns:p14="http://schemas.microsoft.com/office/powerpoint/2010/main" val="3763785385"/>
       </p:ext>
     </p:extLst>
   </p:cSld>
@@ -13540,7 +14333,7 @@
           <p:cNvPr id="2" name="Título 1">
             <a:extLst>
               <a:ext uri="{FF2B5EF4-FFF2-40B4-BE49-F238E27FC236}">
-                <a16:creationId xmlns:a16="http://schemas.microsoft.com/office/drawing/2014/main" id="{EAE0818E-5888-3863-0440-D67FC23CBC6C}"/>
+                <a16:creationId xmlns:a16="http://schemas.microsoft.com/office/drawing/2014/main" id="{663373FA-900C-90C5-5A16-9998A7DC7439}"/>
               </a:ext>
             </a:extLst>
           </p:cNvPr>
@@ -13568,7 +14361,7 @@
           <p:cNvPr id="3" name="Marcador de contenido 2">
             <a:extLst>
               <a:ext uri="{FF2B5EF4-FFF2-40B4-BE49-F238E27FC236}">
-                <a16:creationId xmlns:a16="http://schemas.microsoft.com/office/drawing/2014/main" id="{E4EB6514-0075-89AD-89C5-DCF0F5E4A584}"/>
+                <a16:creationId xmlns:a16="http://schemas.microsoft.com/office/drawing/2014/main" id="{394509AB-D573-D458-283A-569872D9C6EF}"/>
               </a:ext>
             </a:extLst>
           </p:cNvPr>
@@ -13582,7 +14375,7 @@
         <p:spPr>
           <a:xfrm>
             <a:off x="533398" y="1748474"/>
-            <a:ext cx="5847737" cy="4728524"/>
+            <a:ext cx="5149647" cy="4728524"/>
           </a:xfrm>
         </p:spPr>
         <p:txBody>
@@ -13599,7 +14392,7 @@
             </a:pPr>
             <a:r>
               <a:rPr lang="es-CL" sz="3200" dirty="0"/>
-              <a:t>Permite cargar datos de inventario y dejar un comentario a cada material</a:t>
+              <a:t>Una vez con la sesión iniciada y el QR escaneado aparecerá la siguiente pagina</a:t>
             </a:r>
           </a:p>
         </p:txBody>
@@ -13609,7 +14402,7 @@
           <p:cNvPr id="5" name="Imagen 4">
             <a:extLst>
               <a:ext uri="{FF2B5EF4-FFF2-40B4-BE49-F238E27FC236}">
-                <a16:creationId xmlns:a16="http://schemas.microsoft.com/office/drawing/2014/main" id="{9653C664-4487-752F-DFBB-B5646B9175EC}"/>
+                <a16:creationId xmlns:a16="http://schemas.microsoft.com/office/drawing/2014/main" id="{B4EE2941-3D2A-1E80-096E-FC917543F9FC}"/>
               </a:ext>
             </a:extLst>
           </p:cNvPr>
@@ -13626,8 +14419,8 @@
         </p:blipFill>
         <p:spPr>
           <a:xfrm>
-            <a:off x="7506860" y="2318568"/>
-            <a:ext cx="4319052" cy="3588336"/>
+            <a:off x="8382254" y="1495039"/>
+            <a:ext cx="2644369" cy="5235394"/>
           </a:xfrm>
           <a:prstGeom prst="rect">
             <a:avLst/>
@@ -13637,7 +14430,7 @@
     </p:spTree>
     <p:extLst>
       <p:ext uri="{BB962C8B-B14F-4D97-AF65-F5344CB8AC3E}">
-        <p14:creationId xmlns:p14="http://schemas.microsoft.com/office/powerpoint/2010/main" val="1938955807"/>
+        <p14:creationId xmlns:p14="http://schemas.microsoft.com/office/powerpoint/2010/main" val="2754568070"/>
       </p:ext>
     </p:extLst>
   </p:cSld>
@@ -13669,7 +14462,7 @@
           <p:cNvPr id="2" name="Título 1">
             <a:extLst>
               <a:ext uri="{FF2B5EF4-FFF2-40B4-BE49-F238E27FC236}">
-                <a16:creationId xmlns:a16="http://schemas.microsoft.com/office/drawing/2014/main" id="{B052CE3F-8D97-0069-638D-42C3B0AE3920}"/>
+                <a16:creationId xmlns:a16="http://schemas.microsoft.com/office/drawing/2014/main" id="{EAE0818E-5888-3863-0440-D67FC23CBC6C}"/>
               </a:ext>
             </a:extLst>
           </p:cNvPr>
@@ -13697,7 +14490,7 @@
           <p:cNvPr id="3" name="Marcador de contenido 2">
             <a:extLst>
               <a:ext uri="{FF2B5EF4-FFF2-40B4-BE49-F238E27FC236}">
-                <a16:creationId xmlns:a16="http://schemas.microsoft.com/office/drawing/2014/main" id="{1F9D4A1E-8F79-7B41-B31C-E8E4D4425BED}"/>
+                <a16:creationId xmlns:a16="http://schemas.microsoft.com/office/drawing/2014/main" id="{E4EB6514-0075-89AD-89C5-DCF0F5E4A584}"/>
               </a:ext>
             </a:extLst>
           </p:cNvPr>
@@ -13711,7 +14504,7 @@
         <p:spPr>
           <a:xfrm>
             <a:off x="533398" y="1748474"/>
-            <a:ext cx="11658600" cy="3156676"/>
+            <a:ext cx="5847737" cy="4728524"/>
           </a:xfrm>
         </p:spPr>
         <p:txBody>
@@ -13728,7 +14521,7 @@
             </a:pPr>
             <a:r>
               <a:rPr lang="es-CL" sz="3200" dirty="0"/>
-              <a:t>Una vez guardados los cambios, aparecerán inmediatamente en la tabla principal, permitiendo que administración tenga datos en tiempo real del conteo hecho</a:t>
+              <a:t>Permite cargar datos de inventario y dejar un comentario a cada material</a:t>
             </a:r>
           </a:p>
         </p:txBody>
@@ -13738,7 +14531,7 @@
           <p:cNvPr id="5" name="Imagen 4">
             <a:extLst>
               <a:ext uri="{FF2B5EF4-FFF2-40B4-BE49-F238E27FC236}">
-                <a16:creationId xmlns:a16="http://schemas.microsoft.com/office/drawing/2014/main" id="{5EF6AEAB-0B2B-E6DF-CC51-06E9E2352719}"/>
+                <a16:creationId xmlns:a16="http://schemas.microsoft.com/office/drawing/2014/main" id="{9653C664-4487-752F-DFBB-B5646B9175EC}"/>
               </a:ext>
             </a:extLst>
           </p:cNvPr>
@@ -13749,136 +14542,14 @@
         </p:nvPicPr>
         <p:blipFill>
           <a:blip r:embed="rId2"/>
-          <a:srcRect t="80470"/>
           <a:stretch>
             <a:fillRect/>
           </a:stretch>
         </p:blipFill>
         <p:spPr>
           <a:xfrm>
-            <a:off x="0" y="6014393"/>
-            <a:ext cx="12192000" cy="283288"/>
-          </a:xfrm>
-          <a:prstGeom prst="rect">
-            <a:avLst/>
-          </a:prstGeom>
-        </p:spPr>
-      </p:pic>
-      <p:pic>
-        <p:nvPicPr>
-          <p:cNvPr id="7" name="Imagen 6">
-            <a:extLst>
-              <a:ext uri="{FF2B5EF4-FFF2-40B4-BE49-F238E27FC236}">
-                <a16:creationId xmlns:a16="http://schemas.microsoft.com/office/drawing/2014/main" id="{ED5D19ED-CD29-AF0C-0202-91356BDF3BD1}"/>
-              </a:ext>
-            </a:extLst>
-          </p:cNvPr>
-          <p:cNvPicPr>
-            <a:picLocks noChangeAspect="1"/>
-          </p:cNvPicPr>
-          <p:nvPr/>
-        </p:nvPicPr>
-        <p:blipFill>
-          <a:blip r:embed="rId2"/>
-          <a:srcRect b="58039"/>
-          <a:stretch>
-            <a:fillRect/>
-          </a:stretch>
-        </p:blipFill>
-        <p:spPr>
-          <a:xfrm>
-            <a:off x="0" y="5418606"/>
-            <a:ext cx="12192000" cy="608645"/>
-          </a:xfrm>
-          <a:prstGeom prst="rect">
-            <a:avLst/>
-          </a:prstGeom>
-        </p:spPr>
-      </p:pic>
-      <p:pic>
-        <p:nvPicPr>
-          <p:cNvPr id="9" name="Imagen 8">
-            <a:extLst>
-              <a:ext uri="{FF2B5EF4-FFF2-40B4-BE49-F238E27FC236}">
-                <a16:creationId xmlns:a16="http://schemas.microsoft.com/office/drawing/2014/main" id="{B4DDC193-7AA6-594A-6BC4-54A39AB9F520}"/>
-              </a:ext>
-            </a:extLst>
-          </p:cNvPr>
-          <p:cNvPicPr>
-            <a:picLocks noChangeAspect="1"/>
-          </p:cNvPicPr>
-          <p:nvPr/>
-        </p:nvPicPr>
-        <p:blipFill>
-          <a:blip r:embed="rId3"/>
-          <a:stretch>
-            <a:fillRect/>
-          </a:stretch>
-        </p:blipFill>
-        <p:spPr>
-          <a:xfrm>
-            <a:off x="3559893" y="4967664"/>
-            <a:ext cx="2962100" cy="402932"/>
-          </a:xfrm>
-          <a:prstGeom prst="rect">
-            <a:avLst/>
-          </a:prstGeom>
-        </p:spPr>
-      </p:pic>
-      <p:pic>
-        <p:nvPicPr>
-          <p:cNvPr id="11" name="Imagen 10">
-            <a:extLst>
-              <a:ext uri="{FF2B5EF4-FFF2-40B4-BE49-F238E27FC236}">
-                <a16:creationId xmlns:a16="http://schemas.microsoft.com/office/drawing/2014/main" id="{19A0E301-E386-5C0C-E5ED-B74C54CD14FE}"/>
-              </a:ext>
-            </a:extLst>
-          </p:cNvPr>
-          <p:cNvPicPr>
-            <a:picLocks noChangeAspect="1"/>
-          </p:cNvPicPr>
-          <p:nvPr/>
-        </p:nvPicPr>
-        <p:blipFill>
-          <a:blip r:embed="rId4"/>
-          <a:stretch>
-            <a:fillRect/>
-          </a:stretch>
-        </p:blipFill>
-        <p:spPr>
-          <a:xfrm>
-            <a:off x="74087" y="4953160"/>
-            <a:ext cx="3358312" cy="404007"/>
-          </a:xfrm>
-          <a:prstGeom prst="rect">
-            <a:avLst/>
-          </a:prstGeom>
-        </p:spPr>
-      </p:pic>
-      <p:pic>
-        <p:nvPicPr>
-          <p:cNvPr id="13" name="Imagen 12">
-            <a:extLst>
-              <a:ext uri="{FF2B5EF4-FFF2-40B4-BE49-F238E27FC236}">
-                <a16:creationId xmlns:a16="http://schemas.microsoft.com/office/drawing/2014/main" id="{A511C7FF-E77C-07F6-8DD4-1E9D7122EB73}"/>
-              </a:ext>
-            </a:extLst>
-          </p:cNvPr>
-          <p:cNvPicPr>
-            <a:picLocks noChangeAspect="1"/>
-          </p:cNvPicPr>
-          <p:nvPr/>
-        </p:nvPicPr>
-        <p:blipFill>
-          <a:blip r:embed="rId5"/>
-          <a:stretch>
-            <a:fillRect/>
-          </a:stretch>
-        </p:blipFill>
-        <p:spPr>
-          <a:xfrm>
-            <a:off x="6661868" y="4983023"/>
-            <a:ext cx="3286415" cy="402932"/>
+            <a:off x="7506860" y="2318568"/>
+            <a:ext cx="4319052" cy="3588336"/>
           </a:xfrm>
           <a:prstGeom prst="rect">
             <a:avLst/>
@@ -13888,7 +14559,7 @@
     </p:spTree>
     <p:extLst>
       <p:ext uri="{BB962C8B-B14F-4D97-AF65-F5344CB8AC3E}">
-        <p14:creationId xmlns:p14="http://schemas.microsoft.com/office/powerpoint/2010/main" val="3149600831"/>
+        <p14:creationId xmlns:p14="http://schemas.microsoft.com/office/powerpoint/2010/main" val="1938955807"/>
       </p:ext>
     </p:extLst>
   </p:cSld>
@@ -13920,7 +14591,7 @@
           <p:cNvPr id="2" name="Título 1">
             <a:extLst>
               <a:ext uri="{FF2B5EF4-FFF2-40B4-BE49-F238E27FC236}">
-                <a16:creationId xmlns:a16="http://schemas.microsoft.com/office/drawing/2014/main" id="{60522010-8600-330B-824C-61D93C716677}"/>
+                <a16:creationId xmlns:a16="http://schemas.microsoft.com/office/drawing/2014/main" id="{B052CE3F-8D97-0069-638D-42C3B0AE3920}"/>
               </a:ext>
             </a:extLst>
           </p:cNvPr>
@@ -13948,7 +14619,7 @@
           <p:cNvPr id="3" name="Marcador de contenido 2">
             <a:extLst>
               <a:ext uri="{FF2B5EF4-FFF2-40B4-BE49-F238E27FC236}">
-                <a16:creationId xmlns:a16="http://schemas.microsoft.com/office/drawing/2014/main" id="{C168B894-749F-5A0C-5994-B22C0CA0E7BC}"/>
+                <a16:creationId xmlns:a16="http://schemas.microsoft.com/office/drawing/2014/main" id="{1F9D4A1E-8F79-7B41-B31C-E8E4D4425BED}"/>
               </a:ext>
             </a:extLst>
           </p:cNvPr>
@@ -13961,8 +14632,8 @@
         </p:nvSpPr>
         <p:spPr>
           <a:xfrm>
-            <a:off x="533399" y="1748474"/>
-            <a:ext cx="5727408" cy="4728524"/>
+            <a:off x="533398" y="1748474"/>
+            <a:ext cx="11658600" cy="3156676"/>
           </a:xfrm>
         </p:spPr>
         <p:txBody>
@@ -13979,7 +14650,7 @@
             </a:pPr>
             <a:r>
               <a:rPr lang="es-CL" sz="3200" dirty="0"/>
-              <a:t>La tabla principal posee filtros y un buscador por descripción de un material o su código, teniendo fácil acceso a datos de códigos, stock, ubicación y características</a:t>
+              <a:t>Una vez guardados los cambios, aparecerán inmediatamente en la tabla principal, permitiendo que administración tenga datos en tiempo real del conteo hecho</a:t>
             </a:r>
           </a:p>
         </p:txBody>
@@ -13989,7 +14660,7 @@
           <p:cNvPr id="5" name="Imagen 4">
             <a:extLst>
               <a:ext uri="{FF2B5EF4-FFF2-40B4-BE49-F238E27FC236}">
-                <a16:creationId xmlns:a16="http://schemas.microsoft.com/office/drawing/2014/main" id="{75924882-90EB-ADC2-6CF0-82E97E06FC53}"/>
+                <a16:creationId xmlns:a16="http://schemas.microsoft.com/office/drawing/2014/main" id="{5EF6AEAB-0B2B-E6DF-CC51-06E9E2352719}"/>
               </a:ext>
             </a:extLst>
           </p:cNvPr>
@@ -14000,14 +14671,136 @@
         </p:nvPicPr>
         <p:blipFill>
           <a:blip r:embed="rId2"/>
+          <a:srcRect t="80470"/>
           <a:stretch>
             <a:fillRect/>
           </a:stretch>
         </p:blipFill>
         <p:spPr>
           <a:xfrm>
-            <a:off x="6260806" y="1820775"/>
-            <a:ext cx="5845047" cy="4656223"/>
+            <a:off x="0" y="6014393"/>
+            <a:ext cx="12192000" cy="283288"/>
+          </a:xfrm>
+          <a:prstGeom prst="rect">
+            <a:avLst/>
+          </a:prstGeom>
+        </p:spPr>
+      </p:pic>
+      <p:pic>
+        <p:nvPicPr>
+          <p:cNvPr id="7" name="Imagen 6">
+            <a:extLst>
+              <a:ext uri="{FF2B5EF4-FFF2-40B4-BE49-F238E27FC236}">
+                <a16:creationId xmlns:a16="http://schemas.microsoft.com/office/drawing/2014/main" id="{ED5D19ED-CD29-AF0C-0202-91356BDF3BD1}"/>
+              </a:ext>
+            </a:extLst>
+          </p:cNvPr>
+          <p:cNvPicPr>
+            <a:picLocks noChangeAspect="1"/>
+          </p:cNvPicPr>
+          <p:nvPr/>
+        </p:nvPicPr>
+        <p:blipFill>
+          <a:blip r:embed="rId2"/>
+          <a:srcRect b="58039"/>
+          <a:stretch>
+            <a:fillRect/>
+          </a:stretch>
+        </p:blipFill>
+        <p:spPr>
+          <a:xfrm>
+            <a:off x="0" y="5418606"/>
+            <a:ext cx="12192000" cy="608645"/>
+          </a:xfrm>
+          <a:prstGeom prst="rect">
+            <a:avLst/>
+          </a:prstGeom>
+        </p:spPr>
+      </p:pic>
+      <p:pic>
+        <p:nvPicPr>
+          <p:cNvPr id="9" name="Imagen 8">
+            <a:extLst>
+              <a:ext uri="{FF2B5EF4-FFF2-40B4-BE49-F238E27FC236}">
+                <a16:creationId xmlns:a16="http://schemas.microsoft.com/office/drawing/2014/main" id="{B4DDC193-7AA6-594A-6BC4-54A39AB9F520}"/>
+              </a:ext>
+            </a:extLst>
+          </p:cNvPr>
+          <p:cNvPicPr>
+            <a:picLocks noChangeAspect="1"/>
+          </p:cNvPicPr>
+          <p:nvPr/>
+        </p:nvPicPr>
+        <p:blipFill>
+          <a:blip r:embed="rId3"/>
+          <a:stretch>
+            <a:fillRect/>
+          </a:stretch>
+        </p:blipFill>
+        <p:spPr>
+          <a:xfrm>
+            <a:off x="3559893" y="4967664"/>
+            <a:ext cx="2962100" cy="402932"/>
+          </a:xfrm>
+          <a:prstGeom prst="rect">
+            <a:avLst/>
+          </a:prstGeom>
+        </p:spPr>
+      </p:pic>
+      <p:pic>
+        <p:nvPicPr>
+          <p:cNvPr id="11" name="Imagen 10">
+            <a:extLst>
+              <a:ext uri="{FF2B5EF4-FFF2-40B4-BE49-F238E27FC236}">
+                <a16:creationId xmlns:a16="http://schemas.microsoft.com/office/drawing/2014/main" id="{19A0E301-E386-5C0C-E5ED-B74C54CD14FE}"/>
+              </a:ext>
+            </a:extLst>
+          </p:cNvPr>
+          <p:cNvPicPr>
+            <a:picLocks noChangeAspect="1"/>
+          </p:cNvPicPr>
+          <p:nvPr/>
+        </p:nvPicPr>
+        <p:blipFill>
+          <a:blip r:embed="rId4"/>
+          <a:stretch>
+            <a:fillRect/>
+          </a:stretch>
+        </p:blipFill>
+        <p:spPr>
+          <a:xfrm>
+            <a:off x="74087" y="4953160"/>
+            <a:ext cx="3358312" cy="404007"/>
+          </a:xfrm>
+          <a:prstGeom prst="rect">
+            <a:avLst/>
+          </a:prstGeom>
+        </p:spPr>
+      </p:pic>
+      <p:pic>
+        <p:nvPicPr>
+          <p:cNvPr id="13" name="Imagen 12">
+            <a:extLst>
+              <a:ext uri="{FF2B5EF4-FFF2-40B4-BE49-F238E27FC236}">
+                <a16:creationId xmlns:a16="http://schemas.microsoft.com/office/drawing/2014/main" id="{A511C7FF-E77C-07F6-8DD4-1E9D7122EB73}"/>
+              </a:ext>
+            </a:extLst>
+          </p:cNvPr>
+          <p:cNvPicPr>
+            <a:picLocks noChangeAspect="1"/>
+          </p:cNvPicPr>
+          <p:nvPr/>
+        </p:nvPicPr>
+        <p:blipFill>
+          <a:blip r:embed="rId5"/>
+          <a:stretch>
+            <a:fillRect/>
+          </a:stretch>
+        </p:blipFill>
+        <p:spPr>
+          <a:xfrm>
+            <a:off x="6661868" y="4983023"/>
+            <a:ext cx="3286415" cy="402932"/>
           </a:xfrm>
           <a:prstGeom prst="rect">
             <a:avLst/>
@@ -14017,7 +14810,7 @@
     </p:spTree>
     <p:extLst>
       <p:ext uri="{BB962C8B-B14F-4D97-AF65-F5344CB8AC3E}">
-        <p14:creationId xmlns:p14="http://schemas.microsoft.com/office/powerpoint/2010/main" val="4036243683"/>
+        <p14:creationId xmlns:p14="http://schemas.microsoft.com/office/powerpoint/2010/main" val="3149600831"/>
       </p:ext>
     </p:extLst>
   </p:cSld>
@@ -14286,4 +15079,319 @@
     </a:ext>
   </a:extLst>
 </a:theme>
+</file>
+
+<file path=ppt/theme/theme2.xml><?xml version="1.0" encoding="utf-8"?>
+<a:theme xmlns:a="http://schemas.openxmlformats.org/drawingml/2006/main" name="Tema de Office">
+  <a:themeElements>
+    <a:clrScheme name="Office">
+      <a:dk1>
+        <a:sysClr val="windowText" lastClr="000000"/>
+      </a:dk1>
+      <a:lt1>
+        <a:sysClr val="window" lastClr="FFFFFF"/>
+      </a:lt1>
+      <a:dk2>
+        <a:srgbClr val="0E2841"/>
+      </a:dk2>
+      <a:lt2>
+        <a:srgbClr val="E8E8E8"/>
+      </a:lt2>
+      <a:accent1>
+        <a:srgbClr val="156082"/>
+      </a:accent1>
+      <a:accent2>
+        <a:srgbClr val="E97132"/>
+      </a:accent2>
+      <a:accent3>
+        <a:srgbClr val="196B24"/>
+      </a:accent3>
+      <a:accent4>
+        <a:srgbClr val="0F9ED5"/>
+      </a:accent4>
+      <a:accent5>
+        <a:srgbClr val="A02B93"/>
+      </a:accent5>
+      <a:accent6>
+        <a:srgbClr val="4EA72E"/>
+      </a:accent6>
+      <a:hlink>
+        <a:srgbClr val="467886"/>
+      </a:hlink>
+      <a:folHlink>
+        <a:srgbClr val="96607D"/>
+      </a:folHlink>
+    </a:clrScheme>
+    <a:fontScheme name="Office">
+      <a:majorFont>
+        <a:latin typeface="Aptos Display" panose="02110004020202020204"/>
+        <a:ea typeface=""/>
+        <a:cs typeface=""/>
+        <a:font script="Jpan" typeface="游ゴシック Light"/>
+        <a:font script="Hang" typeface="맑은 고딕"/>
+        <a:font script="Hans" typeface="等线 Light"/>
+        <a:font script="Hant" typeface="新細明體"/>
+        <a:font script="Arab" typeface="Times New Roman"/>
+        <a:font script="Hebr" typeface="Times New Roman"/>
+        <a:font script="Thai" typeface="Angsana New"/>
+        <a:font script="Ethi" typeface="Nyala"/>
+        <a:font script="Beng" typeface="Vrinda"/>
+        <a:font script="Gujr" typeface="Shruti"/>
+        <a:font script="Khmr" typeface="MoolBoran"/>
+        <a:font script="Knda" typeface="Tunga"/>
+        <a:font script="Guru" typeface="Raavi"/>
+        <a:font script="Cans" typeface="Euphemia"/>
+        <a:font script="Cher" typeface="Plantagenet Cherokee"/>
+        <a:font script="Yiii" typeface="Microsoft Yi Baiti"/>
+        <a:font script="Tibt" typeface="Microsoft Himalaya"/>
+        <a:font script="Thaa" typeface="MV Boli"/>
+        <a:font script="Deva" typeface="Mangal"/>
+        <a:font script="Telu" typeface="Gautami"/>
+        <a:font script="Taml" typeface="Latha"/>
+        <a:font script="Syrc" typeface="Estrangelo Edessa"/>
+        <a:font script="Orya" typeface="Kalinga"/>
+        <a:font script="Mlym" typeface="Kartika"/>
+        <a:font script="Laoo" typeface="DokChampa"/>
+        <a:font script="Sinh" typeface="Iskoola Pota"/>
+        <a:font script="Mong" typeface="Mongolian Baiti"/>
+        <a:font script="Viet" typeface="Times New Roman"/>
+        <a:font script="Uigh" typeface="Microsoft Uighur"/>
+        <a:font script="Geor" typeface="Sylfaen"/>
+        <a:font script="Armn" typeface="Arial"/>
+        <a:font script="Bugi" typeface="Leelawadee UI"/>
+        <a:font script="Bopo" typeface="Microsoft JhengHei"/>
+        <a:font script="Java" typeface="Javanese Text"/>
+        <a:font script="Lisu" typeface="Segoe UI"/>
+        <a:font script="Mymr" typeface="Myanmar Text"/>
+        <a:font script="Nkoo" typeface="Ebrima"/>
+        <a:font script="Olck" typeface="Nirmala UI"/>
+        <a:font script="Osma" typeface="Ebrima"/>
+        <a:font script="Phag" typeface="Phagspa"/>
+        <a:font script="Syrn" typeface="Estrangelo Edessa"/>
+        <a:font script="Syrj" typeface="Estrangelo Edessa"/>
+        <a:font script="Syre" typeface="Estrangelo Edessa"/>
+        <a:font script="Sora" typeface="Nirmala UI"/>
+        <a:font script="Tale" typeface="Microsoft Tai Le"/>
+        <a:font script="Talu" typeface="Microsoft New Tai Lue"/>
+        <a:font script="Tfng" typeface="Ebrima"/>
+      </a:majorFont>
+      <a:minorFont>
+        <a:latin typeface="Aptos" panose="02110004020202020204"/>
+        <a:ea typeface=""/>
+        <a:cs typeface=""/>
+        <a:font script="Jpan" typeface="游ゴシック"/>
+        <a:font script="Hang" typeface="맑은 고딕"/>
+        <a:font script="Hans" typeface="等线"/>
+        <a:font script="Hant" typeface="新細明體"/>
+        <a:font script="Arab" typeface="Arial"/>
+        <a:font script="Hebr" typeface="Arial"/>
+        <a:font script="Thai" typeface="Cordia New"/>
+        <a:font script="Ethi" typeface="Nyala"/>
+        <a:font script="Beng" typeface="Vrinda"/>
+        <a:font script="Gujr" typeface="Shruti"/>
+        <a:font script="Khmr" typeface="DaunPenh"/>
+        <a:font script="Knda" typeface="Tunga"/>
+        <a:font script="Guru" typeface="Raavi"/>
+        <a:font script="Cans" typeface="Euphemia"/>
+        <a:font script="Cher" typeface="Plantagenet Cherokee"/>
+        <a:font script="Yiii" typeface="Microsoft Yi Baiti"/>
+        <a:font script="Tibt" typeface="Microsoft Himalaya"/>
+        <a:font script="Thaa" typeface="MV Boli"/>
+        <a:font script="Deva" typeface="Mangal"/>
+        <a:font script="Telu" typeface="Gautami"/>
+        <a:font script="Taml" typeface="Latha"/>
+        <a:font script="Syrc" typeface="Estrangelo Edessa"/>
+        <a:font script="Orya" typeface="Kalinga"/>
+        <a:font script="Mlym" typeface="Kartika"/>
+        <a:font script="Laoo" typeface="DokChampa"/>
+        <a:font script="Sinh" typeface="Iskoola Pota"/>
+        <a:font script="Mong" typeface="Mongolian Baiti"/>
+        <a:font script="Viet" typeface="Arial"/>
+        <a:font script="Uigh" typeface="Microsoft Uighur"/>
+        <a:font script="Geor" typeface="Sylfaen"/>
+        <a:font script="Armn" typeface="Arial"/>
+        <a:font script="Bugi" typeface="Leelawadee UI"/>
+        <a:font script="Bopo" typeface="Microsoft JhengHei"/>
+        <a:font script="Java" typeface="Javanese Text"/>
+        <a:font script="Lisu" typeface="Segoe UI"/>
+        <a:font script="Mymr" typeface="Myanmar Text"/>
+        <a:font script="Nkoo" typeface="Ebrima"/>
+        <a:font script="Olck" typeface="Nirmala UI"/>
+        <a:font script="Osma" typeface="Ebrima"/>
+        <a:font script="Phag" typeface="Phagspa"/>
+        <a:font script="Syrn" typeface="Estrangelo Edessa"/>
+        <a:font script="Syrj" typeface="Estrangelo Edessa"/>
+        <a:font script="Syre" typeface="Estrangelo Edessa"/>
+        <a:font script="Sora" typeface="Nirmala UI"/>
+        <a:font script="Tale" typeface="Microsoft Tai Le"/>
+        <a:font script="Talu" typeface="Microsoft New Tai Lue"/>
+        <a:font script="Tfng" typeface="Ebrima"/>
+      </a:minorFont>
+    </a:fontScheme>
+    <a:fmtScheme name="Office">
+      <a:fillStyleLst>
+        <a:solidFill>
+          <a:schemeClr val="phClr"/>
+        </a:solidFill>
+        <a:gradFill rotWithShape="1">
+          <a:gsLst>
+            <a:gs pos="0">
+              <a:schemeClr val="phClr">
+                <a:lumMod val="110000"/>
+                <a:satMod val="105000"/>
+                <a:tint val="67000"/>
+              </a:schemeClr>
+            </a:gs>
+            <a:gs pos="50000">
+              <a:schemeClr val="phClr">
+                <a:lumMod val="105000"/>
+                <a:satMod val="103000"/>
+                <a:tint val="73000"/>
+              </a:schemeClr>
+            </a:gs>
+            <a:gs pos="100000">
+              <a:schemeClr val="phClr">
+                <a:lumMod val="105000"/>
+                <a:satMod val="109000"/>
+                <a:tint val="81000"/>
+              </a:schemeClr>
+            </a:gs>
+          </a:gsLst>
+          <a:lin ang="5400000" scaled="0"/>
+        </a:gradFill>
+        <a:gradFill rotWithShape="1">
+          <a:gsLst>
+            <a:gs pos="0">
+              <a:schemeClr val="phClr">
+                <a:satMod val="103000"/>
+                <a:lumMod val="102000"/>
+                <a:tint val="94000"/>
+              </a:schemeClr>
+            </a:gs>
+            <a:gs pos="50000">
+              <a:schemeClr val="phClr">
+                <a:satMod val="110000"/>
+                <a:lumMod val="100000"/>
+                <a:shade val="100000"/>
+              </a:schemeClr>
+            </a:gs>
+            <a:gs pos="100000">
+              <a:schemeClr val="phClr">
+                <a:lumMod val="99000"/>
+                <a:satMod val="120000"/>
+                <a:shade val="78000"/>
+              </a:schemeClr>
+            </a:gs>
+          </a:gsLst>
+          <a:lin ang="5400000" scaled="0"/>
+        </a:gradFill>
+      </a:fillStyleLst>
+      <a:lnStyleLst>
+        <a:ln w="12700" cap="flat" cmpd="sng" algn="ctr">
+          <a:solidFill>
+            <a:schemeClr val="phClr"/>
+          </a:solidFill>
+          <a:prstDash val="solid"/>
+          <a:miter lim="800000"/>
+        </a:ln>
+        <a:ln w="19050" cap="flat" cmpd="sng" algn="ctr">
+          <a:solidFill>
+            <a:schemeClr val="phClr"/>
+          </a:solidFill>
+          <a:prstDash val="solid"/>
+          <a:miter lim="800000"/>
+        </a:ln>
+        <a:ln w="25400" cap="flat" cmpd="sng" algn="ctr">
+          <a:solidFill>
+            <a:schemeClr val="phClr"/>
+          </a:solidFill>
+          <a:prstDash val="solid"/>
+          <a:miter lim="800000"/>
+        </a:ln>
+      </a:lnStyleLst>
+      <a:effectStyleLst>
+        <a:effectStyle>
+          <a:effectLst/>
+        </a:effectStyle>
+        <a:effectStyle>
+          <a:effectLst/>
+        </a:effectStyle>
+        <a:effectStyle>
+          <a:effectLst>
+            <a:outerShdw blurRad="57150" dist="19050" dir="5400000" algn="ctr" rotWithShape="0">
+              <a:srgbClr val="000000">
+                <a:alpha val="63000"/>
+              </a:srgbClr>
+            </a:outerShdw>
+          </a:effectLst>
+        </a:effectStyle>
+      </a:effectStyleLst>
+      <a:bgFillStyleLst>
+        <a:solidFill>
+          <a:schemeClr val="phClr"/>
+        </a:solidFill>
+        <a:solidFill>
+          <a:schemeClr val="phClr">
+            <a:tint val="95000"/>
+            <a:satMod val="170000"/>
+          </a:schemeClr>
+        </a:solidFill>
+        <a:gradFill rotWithShape="1">
+          <a:gsLst>
+            <a:gs pos="0">
+              <a:schemeClr val="phClr">
+                <a:tint val="93000"/>
+                <a:satMod val="150000"/>
+                <a:shade val="98000"/>
+                <a:lumMod val="102000"/>
+              </a:schemeClr>
+            </a:gs>
+            <a:gs pos="50000">
+              <a:schemeClr val="phClr">
+                <a:tint val="98000"/>
+                <a:satMod val="130000"/>
+                <a:shade val="90000"/>
+                <a:lumMod val="103000"/>
+              </a:schemeClr>
+            </a:gs>
+            <a:gs pos="100000">
+              <a:schemeClr val="phClr">
+                <a:shade val="63000"/>
+                <a:satMod val="120000"/>
+              </a:schemeClr>
+            </a:gs>
+          </a:gsLst>
+          <a:lin ang="5400000" scaled="0"/>
+        </a:gradFill>
+      </a:bgFillStyleLst>
+    </a:fmtScheme>
+  </a:themeElements>
+  <a:objectDefaults>
+    <a:lnDef>
+      <a:spPr/>
+      <a:bodyPr/>
+      <a:lstStyle/>
+      <a:style>
+        <a:lnRef idx="2">
+          <a:schemeClr val="accent1"/>
+        </a:lnRef>
+        <a:fillRef idx="0">
+          <a:schemeClr val="accent1"/>
+        </a:fillRef>
+        <a:effectRef idx="1">
+          <a:schemeClr val="accent1"/>
+        </a:effectRef>
+        <a:fontRef idx="minor">
+          <a:schemeClr val="tx1"/>
+        </a:fontRef>
+      </a:style>
+    </a:lnDef>
+  </a:objectDefaults>
+  <a:extraClrSchemeLst/>
+  <a:extLst>
+    <a:ext uri="{05A4C25C-085E-4340-85A3-A5531E510DB2}">
+      <thm15:themeFamily xmlns:thm15="http://schemas.microsoft.com/office/thememl/2012/main" name="Office Theme" id="{2E142A2C-CD16-42D6-873A-C26D2A0506FA}" vid="{1BDDFF52-6CD6-40A5-AB3C-68EB2F1E4D0A}"/>
+    </a:ext>
+  </a:extLst>
+</a:theme>
 </file>
</xml_diff>